<commit_message>
Add the Forecast tab, monthly Lead reports, and id-based Lead fields
- Forecast tab: scenario projections (best/realistic/worst) toward targets
  across seven lenses, with required run-rate and a what-to-change panel
- Communication panel: monthly Lead reports stored in a new `report` table
  (DB v6), generated as PDFs with an email send simulation
- Leads are now id-based references into the user list on plan, region,
  country, donor, programme and project (replacing free-text `lead`)
- start.bat: verify a busy port actually serves this app, else try the next

Co-Authored-By: Claude Fable 5 <noreply@anthropic.com>
</commit_message>
<xml_diff>
--- a/docs/The-Grassroots-Platform-Overview.pptx
+++ b/docs/The-Grassroots-Platform-Overview.pptx
@@ -4,6 +4,9 @@
   <p:sldMasterIdLst>
     <p:sldMasterId id="2147483648" r:id="rId1"/>
   </p:sldMasterIdLst>
+  <p:notesMasterIdLst>
+    <p:notesMasterId r:id="rId14"/>
+  </p:notesMasterIdLst>
   <p:sldIdLst>
     <p:sldId id="256" r:id="rId2"/>
     <p:sldId id="257" r:id="rId3"/>
@@ -18,9 +21,6 @@
     <p:sldId id="266" r:id="rId12"/>
     <p:sldId id="267" r:id="rId13"/>
   </p:sldIdLst>
-  <p:notesMasterIdLst>
-    <p:notesMasterId r:id="rId14"/>
-  </p:notesMasterIdLst>
   <p:sldSz cx="12192000" cy="6858000"/>
   <p:notesSz cx="6858000" cy="12192000"/>
   <p:defaultTextStyle>
@@ -115,6 +115,11 @@
       </a:defRPr>
     </a:lvl9pPr>
   </p:defaultTextStyle>
+  <p:extLst>
+    <p:ext uri="{EFAFB233-063F-42B5-8137-9DF3F51BA10A}">
+      <p15:sldGuideLst xmlns:p15="http://schemas.microsoft.com/office/powerpoint/2012/main"/>
+    </p:ext>
+  </p:extLst>
 </p:presentation>
 </file>
 
@@ -140,234 +145,10 @@
           <a:chExt cx="0" cy="0"/>
         </a:xfrm>
       </p:grpSpPr>
-      <p:sp>
-        <p:nvSpPr>
-          <p:cNvPr id="2" name="Header Placeholder 1"/>
-          <p:cNvSpPr>
-            <a:spLocks noGrp="1"/>
-          </p:cNvSpPr>
-          <p:nvPr>
-            <p:ph type="hdr" sz="quarter"/>
-          </p:nvPr>
-        </p:nvSpPr>
-        <p:spPr>
-          <a:xfrm>
-            <a:off x="0" y="0"/>
-            <a:ext cx="2971800" cy="458788"/>
-          </a:xfrm>
-          <a:prstGeom prst="rect">
-            <a:avLst/>
-          </a:prstGeom>
-        </p:spPr>
-        <p:txBody>
-          <a:bodyPr vert="horz" lIns="91440" tIns="45720" rIns="91440" bIns="45720" rtlCol="0"/>
-          <a:lstStyle>
-            <a:lvl1pPr algn="l">
-              <a:defRPr sz="1200"/>
-            </a:lvl1pPr>
-          </a:lstStyle>
-          <a:p>
-            <a:endParaRPr lang="en-US"/>
-          </a:p>
-        </p:txBody>
-      </p:sp>
-      <p:sp>
-        <p:nvSpPr>
-          <p:cNvPr id="3" name="Date Placeholder 2"/>
-          <p:cNvSpPr>
-            <a:spLocks noGrp="1"/>
-          </p:cNvSpPr>
-          <p:nvPr>
-            <p:ph type="dt" idx="1"/>
-          </p:nvPr>
-        </p:nvSpPr>
-        <p:spPr>
-          <a:xfrm>
-            <a:off x="3884613" y="0"/>
-            <a:ext cx="2971800" cy="458788"/>
-          </a:xfrm>
-          <a:prstGeom prst="rect">
-            <a:avLst/>
-          </a:prstGeom>
-        </p:spPr>
-        <p:txBody>
-          <a:bodyPr vert="horz" lIns="91440" tIns="45720" rIns="91440" bIns="45720" rtlCol="0"/>
-          <a:lstStyle>
-            <a:lvl1pPr algn="r">
-              <a:defRPr sz="1200"/>
-            </a:lvl1pPr>
-          </a:lstStyle>
-          <a:p>
-            <a:fld id="{5282F153-3F37-0F45-9E97-73ACFA13230C}" type="datetimeFigureOut">
-              <a:rPr lang="en-US"/>
-              <a:t>7/23/19</a:t>
-            </a:fld>
-            <a:endParaRPr lang="en-US"/>
-          </a:p>
-        </p:txBody>
-      </p:sp>
-      <p:sp>
-        <p:nvSpPr>
-          <p:cNvPr id="4" name="Slide Image Placeholder 3"/>
-          <p:cNvSpPr>
-            <a:spLocks noGrp="1" noRot="1" noChangeAspect="1"/>
-          </p:cNvSpPr>
-          <p:nvPr>
-            <p:ph type="sldImg" idx="2"/>
-          </p:nvPr>
-        </p:nvSpPr>
-        <p:spPr>
-          <a:xfrm>
-            <a:off x="685800" y="1143000"/>
-            <a:ext cx="5486400" cy="3086100"/>
-          </a:xfrm>
-          <a:prstGeom prst="rect">
-            <a:avLst/>
-          </a:prstGeom>
-          <a:noFill/>
-          <a:ln w="12700">
-            <a:solidFill>
-              <a:prstClr val="black"/>
-            </a:solidFill>
-          </a:ln>
-        </p:spPr>
-        <p:txBody>
-          <a:bodyPr vert="horz" lIns="91440" tIns="45720" rIns="91440" bIns="45720" rtlCol="0" anchor="ctr"/>
-          <a:lstStyle/>
-          <a:p>
-            <a:endParaRPr lang="en-US"/>
-          </a:p>
-        </p:txBody>
-      </p:sp>
-      <p:sp>
-        <p:nvSpPr>
-          <p:cNvPr id="5" name="Notes Placeholder 4"/>
-          <p:cNvSpPr>
-            <a:spLocks noGrp="1"/>
-          </p:cNvSpPr>
-          <p:nvPr>
-            <p:ph type="body" sz="quarter" idx="3"/>
-          </p:nvPr>
-        </p:nvSpPr>
-        <p:spPr>
-          <a:xfrm>
-            <a:off x="685800" y="4400550"/>
-            <a:ext cx="5486400" cy="3600450"/>
-          </a:xfrm>
-          <a:prstGeom prst="rect">
-            <a:avLst/>
-          </a:prstGeom>
-        </p:spPr>
-        <p:txBody>
-          <a:bodyPr vert="horz" lIns="91440" tIns="45720" rIns="91440" bIns="45720" rtlCol="0"/>
-          <a:lstStyle/>
-          <a:p>
-            <a:pPr lvl="0"/>
-            <a:r>
-              <a:rPr lang="en-US"/>
-              <a:t>Click to edit Master text styles</a:t>
-            </a:r>
-          </a:p>
-          <a:p>
-            <a:pPr lvl="1"/>
-            <a:r>
-              <a:rPr lang="en-US"/>
-              <a:t>Second level</a:t>
-            </a:r>
-          </a:p>
-          <a:p>
-            <a:pPr lvl="2"/>
-            <a:r>
-              <a:rPr lang="en-US"/>
-              <a:t>Third level</a:t>
-            </a:r>
-          </a:p>
-          <a:p>
-            <a:pPr lvl="3"/>
-            <a:r>
-              <a:rPr lang="en-US"/>
-              <a:t>Fourth level</a:t>
-            </a:r>
-          </a:p>
-          <a:p>
-            <a:pPr lvl="4"/>
-            <a:r>
-              <a:rPr lang="en-US"/>
-              <a:t>Fifth level</a:t>
-            </a:r>
-          </a:p>
-        </p:txBody>
-      </p:sp>
-      <p:sp>
-        <p:nvSpPr>
-          <p:cNvPr id="6" name="Footer Placeholder 5"/>
-          <p:cNvSpPr>
-            <a:spLocks noGrp="1"/>
-          </p:cNvSpPr>
-          <p:nvPr>
-            <p:ph type="ftr" sz="quarter" idx="4"/>
-          </p:nvPr>
-        </p:nvSpPr>
-        <p:spPr>
-          <a:xfrm>
-            <a:off x="0" y="8685213"/>
-            <a:ext cx="2971800" cy="458787"/>
-          </a:xfrm>
-          <a:prstGeom prst="rect">
-            <a:avLst/>
-          </a:prstGeom>
-        </p:spPr>
-        <p:txBody>
-          <a:bodyPr vert="horz" lIns="91440" tIns="45720" rIns="91440" bIns="45720" rtlCol="0" anchor="b"/>
-          <a:lstStyle>
-            <a:lvl1pPr algn="l">
-              <a:defRPr sz="1200"/>
-            </a:lvl1pPr>
-          </a:lstStyle>
-          <a:p>
-            <a:endParaRPr lang="en-US"/>
-          </a:p>
-        </p:txBody>
-      </p:sp>
-      <p:sp>
-        <p:nvSpPr>
-          <p:cNvPr id="7" name="Slide Number Placeholder 6"/>
-          <p:cNvSpPr>
-            <a:spLocks noGrp="1"/>
-          </p:cNvSpPr>
-          <p:nvPr>
-            <p:ph type="sldNum" sz="quarter" idx="5"/>
-          </p:nvPr>
-        </p:nvSpPr>
-        <p:spPr>
-          <a:xfrm>
-            <a:off x="3884613" y="8685213"/>
-            <a:ext cx="2971800" cy="458787"/>
-          </a:xfrm>
-          <a:prstGeom prst="rect">
-            <a:avLst/>
-          </a:prstGeom>
-        </p:spPr>
-        <p:txBody>
-          <a:bodyPr vert="horz" lIns="91440" tIns="45720" rIns="91440" bIns="45720" rtlCol="0" anchor="b"/>
-          <a:lstStyle>
-            <a:lvl1pPr algn="r">
-              <a:defRPr sz="1200"/>
-            </a:lvl1pPr>
-          </a:lstStyle>
-          <a:p>
-            <a:fld id="{CE5E9CC1-C706-0F49-92D6-E571CC5EEA8F}" type="slidenum">
-              <a:rPr lang="en-US"/>
-              <a:t>‹#›</a:t>
-            </a:fld>
-            <a:endParaRPr lang="en-US"/>
-          </a:p>
-        </p:txBody>
-      </p:sp>
     </p:spTree>
     <p:extLst>
       <p:ext uri="{BB962C8B-B14F-4D97-AF65-F5344CB8AC3E}">
-        <p14:creationId xmlns:p14="http://schemas.microsoft.com/office/powerpoint/2010/main" val="1024086991"/>
+        <p14:creationId xmlns:p14="http://schemas.microsoft.com/office/powerpoint/2010/main" val="2641316396"/>
       </p:ext>
     </p:extLst>
   </p:cSld>
@@ -515,7 +296,6 @@
               <a:rPr lang="en-US" dirty="0"/>
               <a:t>Open with the promise, not the product. Then say the sample-data line out loud before anything else.</a:t>
             </a:r>
-            <a:endParaRPr lang="en-US" dirty="0"/>
           </a:p>
         </p:txBody>
       </p:sp>
@@ -599,10 +379,6 @@
           <a:bodyPr/>
           <a:lstStyle/>
           <a:p>
-            <a:r>
-              <a:rPr lang="en-US" dirty="0"/>
-              <a:t/>
-            </a:r>
             <a:endParaRPr lang="en-US" dirty="0"/>
           </a:p>
         </p:txBody>
@@ -687,10 +463,6 @@
           <a:bodyPr/>
           <a:lstStyle/>
           <a:p>
-            <a:r>
-              <a:rPr lang="en-US" dirty="0"/>
-              <a:t/>
-            </a:r>
             <a:endParaRPr lang="en-US" dirty="0"/>
           </a:p>
         </p:txBody>
@@ -775,10 +547,6 @@
           <a:bodyPr/>
           <a:lstStyle/>
           <a:p>
-            <a:r>
-              <a:rPr lang="en-US" dirty="0"/>
-              <a:t/>
-            </a:r>
             <a:endParaRPr lang="en-US" dirty="0"/>
           </a:p>
         </p:txBody>
@@ -867,7 +635,6 @@
               <a:rPr lang="en-US" dirty="0"/>
               <a:t>Name their pain in their words. No product yet.</a:t>
             </a:r>
-            <a:endParaRPr lang="en-US" dirty="0"/>
           </a:p>
         </p:txBody>
       </p:sp>
@@ -955,7 +722,6 @@
               <a:rPr lang="en-US" dirty="0"/>
               <a:t>This is the whole idea of the platform in one slide. Pause on it.</a:t>
             </a:r>
-            <a:endParaRPr lang="en-US" dirty="0"/>
           </a:p>
         </p:txBody>
       </p:sp>
@@ -1039,10 +805,6 @@
           <a:bodyPr/>
           <a:lstStyle/>
           <a:p>
-            <a:r>
-              <a:rPr lang="en-US" dirty="0"/>
-              <a:t/>
-            </a:r>
             <a:endParaRPr lang="en-US" dirty="0"/>
           </a:p>
         </p:txBody>
@@ -1127,10 +889,6 @@
           <a:bodyPr/>
           <a:lstStyle/>
           <a:p>
-            <a:r>
-              <a:rPr lang="en-US" dirty="0"/>
-              <a:t/>
-            </a:r>
             <a:endParaRPr lang="en-US" dirty="0"/>
           </a:p>
         </p:txBody>
@@ -1215,10 +973,6 @@
           <a:bodyPr/>
           <a:lstStyle/>
           <a:p>
-            <a:r>
-              <a:rPr lang="en-US" dirty="0"/>
-              <a:t/>
-            </a:r>
             <a:endParaRPr lang="en-US" dirty="0"/>
           </a:p>
         </p:txBody>
@@ -1303,10 +1057,6 @@
           <a:bodyPr/>
           <a:lstStyle/>
           <a:p>
-            <a:r>
-              <a:rPr lang="en-US" dirty="0"/>
-              <a:t/>
-            </a:r>
             <a:endParaRPr lang="en-US" dirty="0"/>
           </a:p>
         </p:txBody>
@@ -1391,10 +1141,6 @@
           <a:bodyPr/>
           <a:lstStyle/>
           <a:p>
-            <a:r>
-              <a:rPr lang="en-US" dirty="0"/>
-              <a:t/>
-            </a:r>
             <a:endParaRPr lang="en-US" dirty="0"/>
           </a:p>
         </p:txBody>
@@ -1479,10 +1225,6 @@
           <a:bodyPr/>
           <a:lstStyle/>
           <a:p>
-            <a:r>
-              <a:rPr lang="en-US" dirty="0"/>
-              <a:t/>
-            </a:r>
             <a:endParaRPr lang="en-US" dirty="0"/>
           </a:p>
         </p:txBody>
@@ -1556,6 +1298,11 @@
 <file path=ppt/slideMasters/slideMaster1.xml><?xml version="1.0" encoding="utf-8"?>
 <p:sldMaster xmlns:a="http://schemas.openxmlformats.org/drawingml/2006/main" xmlns:r="http://schemas.openxmlformats.org/officeDocument/2006/relationships" xmlns:p="http://schemas.openxmlformats.org/presentationml/2006/main">
   <p:cSld>
+    <p:bg>
+      <p:bgRef idx="1001">
+        <a:schemeClr val="bg1"/>
+      </p:bgRef>
+    </p:bg>
     <p:spTree>
       <p:nvGrpSpPr>
         <p:cNvPr id="1" name=""/>
@@ -1838,6 +1585,7 @@
         <a:solidFill>
           <a:srgbClr val="0E2A47"/>
         </a:solidFill>
+        <a:effectLst/>
       </p:bgPr>
     </p:bg>
     <p:spTree>
@@ -1962,14 +1710,14 @@
       </p:sp>
       <p:pic>
         <p:nvPicPr>
-          <p:cNvPr id="6" name="Image 0" descr="C:\Users\shamo\AppData\Local\Temp\claude\C--Users-shamo-OneDrive---United-Nations-UN-DCO-10---Innovation-Sanbox-The-Grassroots\0eee3bdb-6389-4071-99a7-070b782b3283\scratchpad\iconpng\globe.png">    </p:cNvPr>
+          <p:cNvPr id="6" name="Image 0" descr="C:\Users\shamo\AppData\Local\Temp\claude\C--Users-shamo-OneDrive---United-Nations-UN-DCO-10---Innovation-Sanbox-The-Grassroots\0eee3bdb-6389-4071-99a7-070b782b3283\scratchpad\iconpng\globe.png"/>
           <p:cNvPicPr>
             <a:picLocks noChangeAspect="1"/>
           </p:cNvPicPr>
           <p:nvPr/>
         </p:nvPicPr>
         <p:blipFill>
-          <a:blip r:embed="rId1"/>
+          <a:blip r:embed="rId3"/>
           <a:stretch>
             <a:fillRect/>
           </a:stretch>
@@ -2005,11 +1753,11 @@
           <a:bodyPr wrap="square" lIns="0" tIns="0" rIns="0" bIns="0" rtlCol="0" anchor="ctr"/>
           <a:lstStyle/>
           <a:p>
-            <a:pPr indent="0" marL="0">
-              <a:buNone/>
-            </a:pPr>
-            <a:r>
-              <a:rPr lang="en-US" sz="1500" b="1" spc="400" kern="0" dirty="0">
+            <a:pPr marL="0" indent="0">
+              <a:buNone/>
+            </a:pPr>
+            <a:r>
+              <a:rPr lang="en-US" sz="1500" b="1" kern="0" spc="400" dirty="0">
                 <a:solidFill>
                   <a:srgbClr val="9CC4EC"/>
                 </a:solidFill>
@@ -2044,7 +1792,7 @@
           <a:bodyPr wrap="square" lIns="0" tIns="0" rIns="0" bIns="0" rtlCol="0" anchor="ctr"/>
           <a:lstStyle/>
           <a:p>
-            <a:pPr indent="0" marL="0">
+            <a:pPr marL="0" indent="0">
               <a:buNone/>
             </a:pPr>
             <a:r>
@@ -2061,7 +1809,7 @@
             <a:endParaRPr lang="en-US" sz="6000" dirty="0"/>
           </a:p>
           <a:p>
-            <a:pPr indent="0" marL="0">
+            <a:pPr marL="0" indent="0">
               <a:buNone/>
             </a:pPr>
             <a:r>
@@ -2100,7 +1848,7 @@
           <a:bodyPr wrap="square" lIns="0" tIns="0" rIns="0" bIns="0" rtlCol="0" anchor="ctr"/>
           <a:lstStyle/>
           <a:p>
-            <a:pPr indent="0" marL="0">
+            <a:pPr marL="0" indent="0">
               <a:buNone/>
             </a:pPr>
             <a:r>
@@ -2147,14 +1895,14 @@
       </p:sp>
       <p:pic>
         <p:nvPicPr>
-          <p:cNvPr id="11" name="Image 1" descr="C:\Users\shamo\AppData\Local\Temp\claude\C--Users-shamo-OneDrive---United-Nations-UN-DCO-10---Innovation-Sanbox-The-Grassroots\0eee3bdb-6389-4071-99a7-070b782b3283\scratchpad\iconpng\lightbulb.png">    </p:cNvPr>
+          <p:cNvPr id="11" name="Image 1" descr="C:\Users\shamo\AppData\Local\Temp\claude\C--Users-shamo-OneDrive---United-Nations-UN-DCO-10---Innovation-Sanbox-The-Grassroots\0eee3bdb-6389-4071-99a7-070b782b3283\scratchpad\iconpng\lightbulb.png"/>
           <p:cNvPicPr>
             <a:picLocks noChangeAspect="1"/>
           </p:cNvPicPr>
           <p:nvPr/>
         </p:nvPicPr>
         <p:blipFill>
-          <a:blip r:embed="rId2"/>
+          <a:blip r:embed="rId4"/>
           <a:stretch>
             <a:fillRect/>
           </a:stretch>
@@ -2190,7 +1938,7 @@
           <a:bodyPr wrap="square" lIns="0" tIns="0" rIns="0" bIns="0" rtlCol="0" anchor="ctr"/>
           <a:lstStyle/>
           <a:p>
-            <a:pPr indent="0" marL="0">
+            <a:pPr marL="0" indent="0">
               <a:buNone/>
             </a:pPr>
             <a:r>
@@ -2204,9 +1952,6 @@
               </a:rPr>
               <a:t>A live demonstration — with sample data.  </a:t>
             </a:r>
-            <a:pPr indent="0" marL="0">
-              <a:buNone/>
-            </a:pPr>
             <a:r>
               <a:rPr lang="en-US" sz="1250" dirty="0">
                 <a:solidFill>
@@ -2243,7 +1988,7 @@
           <a:bodyPr wrap="square" lIns="0" tIns="0" rIns="0" bIns="0" rtlCol="0" anchor="ctr"/>
           <a:lstStyle/>
           <a:p>
-            <a:pPr indent="0" marL="0">
+            <a:pPr marL="0" indent="0">
               <a:buNone/>
             </a:pPr>
             <a:r>
@@ -2267,7 +2012,7 @@
     <a:masterClrMapping/>
   </p:clrMapOvr>
   <p:transition spd="slow">
-    <p:push dir="l"/>
+    <p:push/>
   </p:transition>
 </p:sld>
 </file>
@@ -2280,6 +2025,7 @@
         <a:solidFill>
           <a:srgbClr val="FFFFFF"/>
         </a:solidFill>
+        <a:effectLst/>
       </p:bgPr>
     </p:bg>
     <p:spTree>
@@ -2317,11 +2063,11 @@
           <a:bodyPr wrap="square" lIns="0" tIns="0" rIns="0" bIns="0" rtlCol="0" anchor="ctr"/>
           <a:lstStyle/>
           <a:p>
-            <a:pPr indent="0" marL="0">
-              <a:buNone/>
-            </a:pPr>
-            <a:r>
-              <a:rPr lang="en-US" sz="1200" b="1" spc="300" kern="0" dirty="0">
+            <a:pPr marL="0" indent="0">
+              <a:buNone/>
+            </a:pPr>
+            <a:r>
+              <a:rPr lang="en-US" sz="1200" b="1" kern="0" spc="300" dirty="0">
                 <a:solidFill>
                   <a:srgbClr val="1B6FC2"/>
                 </a:solidFill>
@@ -2356,7 +2102,7 @@
           <a:bodyPr wrap="square" lIns="0" tIns="0" rIns="0" bIns="0" rtlCol="0" anchor="ctr"/>
           <a:lstStyle/>
           <a:p>
-            <a:pPr indent="0" marL="0">
+            <a:pPr marL="0" indent="0">
               <a:buNone/>
             </a:pPr>
             <a:r>
@@ -2395,7 +2141,7 @@
           <a:bodyPr wrap="square" lIns="0" tIns="0" rIns="0" bIns="0" rtlCol="0" anchor="ctr"/>
           <a:lstStyle/>
           <a:p>
-            <a:pPr indent="0" marL="0">
+            <a:pPr marL="0" indent="0">
               <a:buNone/>
             </a:pPr>
             <a:r>
@@ -2467,14 +2213,14 @@
       </p:sp>
       <p:pic>
         <p:nvPicPr>
-          <p:cNvPr id="7" name="Image 0" descr="C:\Users\shamo\AppData\Local\Temp\claude\C--Users-shamo-OneDrive---United-Nations-UN-DCO-10---Innovation-Sanbox-The-Grassroots\0eee3bdb-6389-4071-99a7-070b782b3283\scratchpad\iconpng\laptop.png">    </p:cNvPr>
+          <p:cNvPr id="7" name="Image 0" descr="C:\Users\shamo\AppData\Local\Temp\claude\C--Users-shamo-OneDrive---United-Nations-UN-DCO-10---Innovation-Sanbox-The-Grassroots\0eee3bdb-6389-4071-99a7-070b782b3283\scratchpad\iconpng\laptop.png"/>
           <p:cNvPicPr>
             <a:picLocks noChangeAspect="1"/>
           </p:cNvPicPr>
           <p:nvPr/>
         </p:nvPicPr>
         <p:blipFill>
-          <a:blip r:embed="rId1"/>
+          <a:blip r:embed="rId3"/>
           <a:stretch>
             <a:fillRect/>
           </a:stretch>
@@ -2510,7 +2256,7 @@
           <a:bodyPr wrap="square" lIns="0" tIns="0" rIns="0" bIns="0" rtlCol="0" anchor="t"/>
           <a:lstStyle/>
           <a:p>
-            <a:pPr indent="0" marL="0">
+            <a:pPr marL="0" indent="0">
               <a:buNone/>
             </a:pPr>
             <a:r>
@@ -2549,7 +2295,7 @@
           <a:bodyPr wrap="square" lIns="0" tIns="0" rIns="0" bIns="0" rtlCol="0" anchor="t"/>
           <a:lstStyle/>
           <a:p>
-            <a:pPr indent="0" marL="0">
+            <a:pPr marL="0" indent="0">
               <a:buNone/>
             </a:pPr>
             <a:r>
@@ -2621,14 +2367,14 @@
       </p:sp>
       <p:pic>
         <p:nvPicPr>
-          <p:cNvPr id="12" name="Image 1" descr="C:\Users\shamo\AppData\Local\Temp\claude\C--Users-shamo-OneDrive---United-Nations-UN-DCO-10---Innovation-Sanbox-The-Grassroots\0eee3bdb-6389-4071-99a7-070b782b3283\scratchpad\iconpng\rocketBlue.png">    </p:cNvPr>
+          <p:cNvPr id="12" name="Image 1" descr="C:\Users\shamo\AppData\Local\Temp\claude\C--Users-shamo-OneDrive---United-Nations-UN-DCO-10---Innovation-Sanbox-The-Grassroots\0eee3bdb-6389-4071-99a7-070b782b3283\scratchpad\iconpng\rocketBlue.png"/>
           <p:cNvPicPr>
             <a:picLocks noChangeAspect="1"/>
           </p:cNvPicPr>
           <p:nvPr/>
         </p:nvPicPr>
         <p:blipFill>
-          <a:blip r:embed="rId2"/>
+          <a:blip r:embed="rId4"/>
           <a:stretch>
             <a:fillRect/>
           </a:stretch>
@@ -2664,7 +2410,7 @@
           <a:bodyPr wrap="square" lIns="0" tIns="0" rIns="0" bIns="0" rtlCol="0" anchor="t"/>
           <a:lstStyle/>
           <a:p>
-            <a:pPr indent="0" marL="0">
+            <a:pPr marL="0" indent="0">
               <a:buNone/>
             </a:pPr>
             <a:r>
@@ -2703,7 +2449,7 @@
           <a:bodyPr wrap="square" lIns="0" tIns="0" rIns="0" bIns="0" rtlCol="0" anchor="t"/>
           <a:lstStyle/>
           <a:p>
-            <a:pPr indent="0" marL="0">
+            <a:pPr marL="0" indent="0">
               <a:buNone/>
             </a:pPr>
             <a:r>
@@ -2775,14 +2521,14 @@
       </p:sp>
       <p:pic>
         <p:nvPicPr>
-          <p:cNvPr id="17" name="Image 2" descr="C:\Users\shamo\AppData\Local\Temp\claude\C--Users-shamo-OneDrive---United-Nations-UN-DCO-10---Innovation-Sanbox-The-Grassroots\0eee3bdb-6389-4071-99a7-070b782b3283\scratchpad\iconpng\shield.png">    </p:cNvPr>
+          <p:cNvPr id="17" name="Image 2" descr="C:\Users\shamo\AppData\Local\Temp\claude\C--Users-shamo-OneDrive---United-Nations-UN-DCO-10---Innovation-Sanbox-The-Grassroots\0eee3bdb-6389-4071-99a7-070b782b3283\scratchpad\iconpng\shield.png"/>
           <p:cNvPicPr>
             <a:picLocks noChangeAspect="1"/>
           </p:cNvPicPr>
           <p:nvPr/>
         </p:nvPicPr>
         <p:blipFill>
-          <a:blip r:embed="rId3"/>
+          <a:blip r:embed="rId5"/>
           <a:stretch>
             <a:fillRect/>
           </a:stretch>
@@ -2818,7 +2564,7 @@
           <a:bodyPr wrap="square" lIns="0" tIns="0" rIns="0" bIns="0" rtlCol="0" anchor="t"/>
           <a:lstStyle/>
           <a:p>
-            <a:pPr indent="0" marL="0">
+            <a:pPr marL="0" indent="0">
               <a:buNone/>
             </a:pPr>
             <a:r>
@@ -2857,7 +2603,7 @@
           <a:bodyPr wrap="square" lIns="0" tIns="0" rIns="0" bIns="0" rtlCol="0" anchor="t"/>
           <a:lstStyle/>
           <a:p>
-            <a:pPr indent="0" marL="0">
+            <a:pPr marL="0" indent="0">
               <a:buNone/>
             </a:pPr>
             <a:r>
@@ -2929,14 +2675,14 @@
       </p:sp>
       <p:pic>
         <p:nvPicPr>
-          <p:cNvPr id="22" name="Image 3" descr="C:\Users\shamo\AppData\Local\Temp\claude\C--Users-shamo-OneDrive---United-Nations-UN-DCO-10---Innovation-Sanbox-The-Grassroots\0eee3bdb-6389-4071-99a7-070b782b3283\scratchpad\iconpng\compass.png">    </p:cNvPr>
+          <p:cNvPr id="22" name="Image 3" descr="C:\Users\shamo\AppData\Local\Temp\claude\C--Users-shamo-OneDrive---United-Nations-UN-DCO-10---Innovation-Sanbox-The-Grassroots\0eee3bdb-6389-4071-99a7-070b782b3283\scratchpad\iconpng\compass.png"/>
           <p:cNvPicPr>
             <a:picLocks noChangeAspect="1"/>
           </p:cNvPicPr>
           <p:nvPr/>
         </p:nvPicPr>
         <p:blipFill>
-          <a:blip r:embed="rId4"/>
+          <a:blip r:embed="rId6"/>
           <a:stretch>
             <a:fillRect/>
           </a:stretch>
@@ -2972,7 +2718,7 @@
           <a:bodyPr wrap="square" lIns="0" tIns="0" rIns="0" bIns="0" rtlCol="0" anchor="t"/>
           <a:lstStyle/>
           <a:p>
-            <a:pPr indent="0" marL="0">
+            <a:pPr marL="0" indent="0">
               <a:buNone/>
             </a:pPr>
             <a:r>
@@ -3011,7 +2757,7 @@
           <a:bodyPr wrap="square" lIns="0" tIns="0" rIns="0" bIns="0" rtlCol="0" anchor="t"/>
           <a:lstStyle/>
           <a:p>
-            <a:pPr indent="0" marL="0">
+            <a:pPr marL="0" indent="0">
               <a:buNone/>
             </a:pPr>
             <a:r>
@@ -3050,7 +2796,7 @@
           <a:bodyPr wrap="square" lIns="0" tIns="0" rIns="0" bIns="0" rtlCol="0" anchor="ctr"/>
           <a:lstStyle/>
           <a:p>
-            <a:pPr indent="0" marL="0">
+            <a:pPr marL="0" indent="0">
               <a:buNone/>
             </a:pPr>
             <a:r>
@@ -3087,6 +2833,7 @@
         <a:solidFill>
           <a:srgbClr val="FFFFFF"/>
         </a:solidFill>
+        <a:effectLst/>
       </p:bgPr>
     </p:bg>
     <p:spTree>
@@ -3124,11 +2871,11 @@
           <a:bodyPr wrap="square" lIns="0" tIns="0" rIns="0" bIns="0" rtlCol="0" anchor="ctr"/>
           <a:lstStyle/>
           <a:p>
-            <a:pPr indent="0" marL="0">
-              <a:buNone/>
-            </a:pPr>
-            <a:r>
-              <a:rPr lang="en-US" sz="1200" b="1" spc="300" kern="0" dirty="0">
+            <a:pPr marL="0" indent="0">
+              <a:buNone/>
+            </a:pPr>
+            <a:r>
+              <a:rPr lang="en-US" sz="1200" b="1" kern="0" spc="300" dirty="0">
                 <a:solidFill>
                   <a:srgbClr val="1B6FC2"/>
                 </a:solidFill>
@@ -3163,7 +2910,7 @@
           <a:bodyPr wrap="square" lIns="0" tIns="0" rIns="0" bIns="0" rtlCol="0" anchor="ctr"/>
           <a:lstStyle/>
           <a:p>
-            <a:pPr indent="0" marL="0">
+            <a:pPr marL="0" indent="0">
               <a:buNone/>
             </a:pPr>
             <a:r>
@@ -3235,14 +2982,14 @@
       </p:sp>
       <p:pic>
         <p:nvPicPr>
-          <p:cNvPr id="6" name="Image 0" descr="C:\Users\shamo\AppData\Local\Temp\claude\C--Users-shamo-OneDrive---United-Nations-UN-DCO-10---Innovation-Sanbox-The-Grassroots\0eee3bdb-6389-4071-99a7-070b782b3283\scratchpad\iconpng\check.png">    </p:cNvPr>
+          <p:cNvPr id="6" name="Image 0" descr="C:\Users\shamo\AppData\Local\Temp\claude\C--Users-shamo-OneDrive---United-Nations-UN-DCO-10---Innovation-Sanbox-The-Grassroots\0eee3bdb-6389-4071-99a7-070b782b3283\scratchpad\iconpng\check.png"/>
           <p:cNvPicPr>
             <a:picLocks noChangeAspect="1"/>
           </p:cNvPicPr>
           <p:nvPr/>
         </p:nvPicPr>
         <p:blipFill>
-          <a:blip r:embed="rId1"/>
+          <a:blip r:embed="rId3"/>
           <a:stretch>
             <a:fillRect/>
           </a:stretch>
@@ -3278,7 +3025,7 @@
           <a:bodyPr wrap="square" lIns="0" tIns="0" rIns="0" bIns="0" rtlCol="0" anchor="ctr"/>
           <a:lstStyle/>
           <a:p>
-            <a:pPr indent="0" marL="0">
+            <a:pPr marL="0" indent="0">
               <a:buNone/>
             </a:pPr>
             <a:r>
@@ -3435,14 +3182,14 @@
       </p:sp>
       <p:pic>
         <p:nvPicPr>
-          <p:cNvPr id="11" name="Image 1" descr="C:\Users\shamo\AppData\Local\Temp\claude\C--Users-shamo-OneDrive---United-Nations-UN-DCO-10---Innovation-Sanbox-The-Grassroots\0eee3bdb-6389-4071-99a7-070b782b3283\scratchpad\iconpng\boltBlue.png">    </p:cNvPr>
+          <p:cNvPr id="11" name="Image 1" descr="C:\Users\shamo\AppData\Local\Temp\claude\C--Users-shamo-OneDrive---United-Nations-UN-DCO-10---Innovation-Sanbox-The-Grassroots\0eee3bdb-6389-4071-99a7-070b782b3283\scratchpad\iconpng\boltBlue.png"/>
           <p:cNvPicPr>
             <a:picLocks noChangeAspect="1"/>
           </p:cNvPicPr>
           <p:nvPr/>
         </p:nvPicPr>
         <p:blipFill>
-          <a:blip r:embed="rId2"/>
+          <a:blip r:embed="rId4"/>
           <a:stretch>
             <a:fillRect/>
           </a:stretch>
@@ -3478,7 +3225,7 @@
           <a:bodyPr wrap="square" lIns="0" tIns="0" rIns="0" bIns="0" rtlCol="0" anchor="ctr"/>
           <a:lstStyle/>
           <a:p>
-            <a:pPr indent="0" marL="0">
+            <a:pPr marL="0" indent="0">
               <a:buNone/>
             </a:pPr>
             <a:r>
@@ -3602,7 +3349,7 @@
           <a:bodyPr wrap="square" lIns="0" tIns="0" rIns="0" bIns="0" rtlCol="0" anchor="ctr"/>
           <a:lstStyle/>
           <a:p>
-            <a:pPr indent="0" marL="0">
+            <a:pPr marL="0" indent="0">
               <a:buNone/>
             </a:pPr>
             <a:r>
@@ -3639,6 +3386,7 @@
         <a:solidFill>
           <a:srgbClr val="0E2A47"/>
         </a:solidFill>
+        <a:effectLst/>
       </p:bgPr>
     </p:bg>
     <p:spTree>
@@ -3730,11 +3478,11 @@
           <a:bodyPr wrap="square" lIns="0" tIns="0" rIns="0" bIns="0" rtlCol="0" anchor="ctr"/>
           <a:lstStyle/>
           <a:p>
-            <a:pPr indent="0" marL="0">
-              <a:buNone/>
-            </a:pPr>
-            <a:r>
-              <a:rPr lang="en-US" sz="1200" b="1" spc="300" kern="0" dirty="0">
+            <a:pPr marL="0" indent="0">
+              <a:buNone/>
+            </a:pPr>
+            <a:r>
+              <a:rPr lang="en-US" sz="1200" b="1" kern="0" spc="300" dirty="0">
                 <a:solidFill>
                   <a:srgbClr val="F5B942"/>
                 </a:solidFill>
@@ -3769,7 +3517,7 @@
           <a:bodyPr wrap="square" lIns="0" tIns="0" rIns="0" bIns="0" rtlCol="0" anchor="ctr"/>
           <a:lstStyle/>
           <a:p>
-            <a:pPr indent="0" marL="0">
+            <a:pPr marL="0" indent="0">
               <a:buNone/>
             </a:pPr>
             <a:r>
@@ -3786,7 +3534,7 @@
             <a:endParaRPr lang="en-US" sz="4000" dirty="0"/>
           </a:p>
           <a:p>
-            <a:pPr indent="0" marL="0">
+            <a:pPr marL="0" indent="0">
               <a:buNone/>
             </a:pPr>
             <a:r>
@@ -3825,7 +3573,7 @@
           <a:bodyPr wrap="square" lIns="0" tIns="0" rIns="0" bIns="0" rtlCol="0" anchor="ctr"/>
           <a:lstStyle/>
           <a:p>
-            <a:pPr indent="0" marL="0">
+            <a:pPr marL="0" indent="0">
               <a:buNone/>
             </a:pPr>
             <a:r>
@@ -3891,7 +3639,7 @@
           <a:bodyPr wrap="square" lIns="0" tIns="0" rIns="0" bIns="0" rtlCol="0" anchor="ctr"/>
           <a:lstStyle/>
           <a:p>
-            <a:pPr indent="0" marL="0">
+            <a:pPr marL="0" indent="0">
               <a:buNone/>
             </a:pPr>
             <a:r>
@@ -3906,9 +3654,6 @@
               <a:t>thegrassroots.github.io/platform
 </a:t>
             </a:r>
-            <a:pPr indent="0" marL="0">
-              <a:buNone/>
-            </a:pPr>
             <a:r>
               <a:rPr lang="en-US" sz="1400" dirty="0">
                 <a:solidFill>
@@ -3972,11 +3717,11 @@
           <a:bodyPr wrap="square" lIns="0" tIns="0" rIns="0" bIns="0" rtlCol="0" anchor="ctr"/>
           <a:lstStyle/>
           <a:p>
-            <a:pPr indent="0" marL="0">
-              <a:buNone/>
-            </a:pPr>
-            <a:r>
-              <a:rPr lang="en-US" sz="1300" b="1" spc="200" kern="0" dirty="0">
+            <a:pPr marL="0" indent="0">
+              <a:buNone/>
+            </a:pPr>
+            <a:r>
+              <a:rPr lang="en-US" sz="1300" b="1" kern="0" spc="200" dirty="0">
                 <a:solidFill>
                   <a:srgbClr val="9CC4EC"/>
                 </a:solidFill>
@@ -3987,9 +3732,6 @@
               <a:t>Talk to us
 </a:t>
             </a:r>
-            <a:pPr indent="0" marL="0">
-              <a:buNone/>
-            </a:pPr>
             <a:r>
               <a:rPr lang="en-US" sz="1550" b="1" dirty="0">
                 <a:solidFill>
@@ -4026,7 +3768,7 @@
           <a:bodyPr wrap="square" lIns="0" tIns="0" rIns="0" bIns="0" rtlCol="0" anchor="ctr"/>
           <a:lstStyle/>
           <a:p>
-            <a:pPr indent="0" marL="0">
+            <a:pPr marL="0" indent="0">
               <a:buNone/>
             </a:pPr>
             <a:r>
@@ -4050,7 +3792,7 @@
     <a:masterClrMapping/>
   </p:clrMapOvr>
   <p:transition spd="slow">
-    <p:push dir="l"/>
+    <p:push/>
   </p:transition>
 </p:sld>
 </file>
@@ -4063,6 +3805,7 @@
         <a:solidFill>
           <a:srgbClr val="FFFFFF"/>
         </a:solidFill>
+        <a:effectLst/>
       </p:bgPr>
     </p:bg>
     <p:spTree>
@@ -4100,11 +3843,11 @@
           <a:bodyPr wrap="square" lIns="0" tIns="0" rIns="0" bIns="0" rtlCol="0" anchor="ctr"/>
           <a:lstStyle/>
           <a:p>
-            <a:pPr indent="0" marL="0">
-              <a:buNone/>
-            </a:pPr>
-            <a:r>
-              <a:rPr lang="en-US" sz="1200" b="1" spc="300" kern="0" dirty="0">
+            <a:pPr marL="0" indent="0">
+              <a:buNone/>
+            </a:pPr>
+            <a:r>
+              <a:rPr lang="en-US" sz="1200" b="1" kern="0" spc="300" dirty="0">
                 <a:solidFill>
                   <a:srgbClr val="1B6FC2"/>
                 </a:solidFill>
@@ -4139,7 +3882,7 @@
           <a:bodyPr wrap="square" lIns="0" tIns="0" rIns="0" bIns="0" rtlCol="0" anchor="ctr"/>
           <a:lstStyle/>
           <a:p>
-            <a:pPr indent="0" marL="0">
+            <a:pPr marL="0" indent="0">
               <a:buNone/>
             </a:pPr>
             <a:r>
@@ -4156,7 +3899,7 @@
             <a:endParaRPr lang="en-US" sz="3300" dirty="0"/>
           </a:p>
           <a:p>
-            <a:pPr indent="0" marL="0">
+            <a:pPr marL="0" indent="0">
               <a:buNone/>
             </a:pPr>
             <a:r>
@@ -4195,7 +3938,7 @@
           <a:bodyPr wrap="square" lIns="0" tIns="0" rIns="0" bIns="0" rtlCol="0" anchor="ctr"/>
           <a:lstStyle/>
           <a:p>
-            <a:pPr indent="0" marL="0">
+            <a:pPr marL="0" indent="0">
               <a:buNone/>
             </a:pPr>
             <a:r>
@@ -4267,14 +4010,14 @@
       </p:sp>
       <p:pic>
         <p:nvPicPr>
-          <p:cNvPr id="7" name="Image 0" descr="C:\Users\shamo\AppData\Local\Temp\claude\C--Users-shamo-OneDrive---United-Nations-UN-DCO-10---Innovation-Sanbox-The-Grassroots\0eee3bdb-6389-4071-99a7-070b782b3283\scratchpad\iconpng\binoculars.png">    </p:cNvPr>
+          <p:cNvPr id="7" name="Image 0" descr="C:\Users\shamo\AppData\Local\Temp\claude\C--Users-shamo-OneDrive---United-Nations-UN-DCO-10---Innovation-Sanbox-The-Grassroots\0eee3bdb-6389-4071-99a7-070b782b3283\scratchpad\iconpng\binoculars.png"/>
           <p:cNvPicPr>
             <a:picLocks noChangeAspect="1"/>
           </p:cNvPicPr>
           <p:nvPr/>
         </p:nvPicPr>
         <p:blipFill>
-          <a:blip r:embed="rId1"/>
+          <a:blip r:embed="rId3"/>
           <a:stretch>
             <a:fillRect/>
           </a:stretch>
@@ -4310,7 +4053,7 @@
           <a:bodyPr wrap="square" lIns="0" tIns="0" rIns="0" bIns="0" rtlCol="0" anchor="t"/>
           <a:lstStyle/>
           <a:p>
-            <a:pPr indent="0" marL="0">
+            <a:pPr marL="0" indent="0">
               <a:buNone/>
             </a:pPr>
             <a:r>
@@ -4349,7 +4092,7 @@
           <a:bodyPr wrap="square" lIns="0" tIns="0" rIns="0" bIns="0" rtlCol="0" anchor="t"/>
           <a:lstStyle/>
           <a:p>
-            <a:pPr indent="0" marL="0">
+            <a:pPr marL="0" indent="0">
               <a:buNone/>
             </a:pPr>
             <a:r>
@@ -4421,14 +4164,14 @@
       </p:sp>
       <p:pic>
         <p:nvPicPr>
-          <p:cNvPr id="12" name="Image 1" descr="C:\Users\shamo\AppData\Local\Temp\claude\C--Users-shamo-OneDrive---United-Nations-UN-DCO-10---Innovation-Sanbox-The-Grassroots\0eee3bdb-6389-4071-99a7-070b782b3283\scratchpad\iconpng\sync.png">    </p:cNvPr>
+          <p:cNvPr id="12" name="Image 1" descr="C:\Users\shamo\AppData\Local\Temp\claude\C--Users-shamo-OneDrive---United-Nations-UN-DCO-10---Innovation-Sanbox-The-Grassroots\0eee3bdb-6389-4071-99a7-070b782b3283\scratchpad\iconpng\sync.png"/>
           <p:cNvPicPr>
             <a:picLocks noChangeAspect="1"/>
           </p:cNvPicPr>
           <p:nvPr/>
         </p:nvPicPr>
         <p:blipFill>
-          <a:blip r:embed="rId2"/>
+          <a:blip r:embed="rId4"/>
           <a:stretch>
             <a:fillRect/>
           </a:stretch>
@@ -4464,7 +4207,7 @@
           <a:bodyPr wrap="square" lIns="0" tIns="0" rIns="0" bIns="0" rtlCol="0" anchor="t"/>
           <a:lstStyle/>
           <a:p>
-            <a:pPr indent="0" marL="0">
+            <a:pPr marL="0" indent="0">
               <a:buNone/>
             </a:pPr>
             <a:r>
@@ -4503,7 +4246,7 @@
           <a:bodyPr wrap="square" lIns="0" tIns="0" rIns="0" bIns="0" rtlCol="0" anchor="t"/>
           <a:lstStyle/>
           <a:p>
-            <a:pPr indent="0" marL="0">
+            <a:pPr marL="0" indent="0">
               <a:buNone/>
             </a:pPr>
             <a:r>
@@ -4575,14 +4318,14 @@
       </p:sp>
       <p:pic>
         <p:nvPicPr>
-          <p:cNvPr id="17" name="Image 2" descr="C:\Users\shamo\AppData\Local\Temp\claude\C--Users-shamo-OneDrive---United-Nations-UN-DCO-10---Innovation-Sanbox-The-Grassroots\0eee3bdb-6389-4071-99a7-070b782b3283\scratchpad\iconpng\eye.png">    </p:cNvPr>
+          <p:cNvPr id="17" name="Image 2" descr="C:\Users\shamo\AppData\Local\Temp\claude\C--Users-shamo-OneDrive---United-Nations-UN-DCO-10---Innovation-Sanbox-The-Grassroots\0eee3bdb-6389-4071-99a7-070b782b3283\scratchpad\iconpng\eye.png"/>
           <p:cNvPicPr>
             <a:picLocks noChangeAspect="1"/>
           </p:cNvPicPr>
           <p:nvPr/>
         </p:nvPicPr>
         <p:blipFill>
-          <a:blip r:embed="rId3"/>
+          <a:blip r:embed="rId5"/>
           <a:stretch>
             <a:fillRect/>
           </a:stretch>
@@ -4618,7 +4361,7 @@
           <a:bodyPr wrap="square" lIns="0" tIns="0" rIns="0" bIns="0" rtlCol="0" anchor="t"/>
           <a:lstStyle/>
           <a:p>
-            <a:pPr indent="0" marL="0">
+            <a:pPr marL="0" indent="0">
               <a:buNone/>
             </a:pPr>
             <a:r>
@@ -4657,7 +4400,7 @@
           <a:bodyPr wrap="square" lIns="0" tIns="0" rIns="0" bIns="0" rtlCol="0" anchor="t"/>
           <a:lstStyle/>
           <a:p>
-            <a:pPr indent="0" marL="0">
+            <a:pPr marL="0" indent="0">
               <a:buNone/>
             </a:pPr>
             <a:r>
@@ -4694,6 +4437,7 @@
         <a:solidFill>
           <a:srgbClr val="0E2A47"/>
         </a:solidFill>
+        <a:effectLst/>
       </p:bgPr>
     </p:bg>
     <p:spTree>
@@ -4785,11 +4529,11 @@
           <a:bodyPr wrap="square" lIns="0" tIns="0" rIns="0" bIns="0" rtlCol="0" anchor="ctr"/>
           <a:lstStyle/>
           <a:p>
-            <a:pPr indent="0" marL="0">
-              <a:buNone/>
-            </a:pPr>
-            <a:r>
-              <a:rPr lang="en-US" sz="1200" b="1" spc="300" kern="0" dirty="0">
+            <a:pPr marL="0" indent="0">
+              <a:buNone/>
+            </a:pPr>
+            <a:r>
+              <a:rPr lang="en-US" sz="1200" b="1" kern="0" spc="300" dirty="0">
                 <a:solidFill>
                   <a:srgbClr val="F5B942"/>
                 </a:solidFill>
@@ -4824,7 +4568,7 @@
           <a:bodyPr wrap="square" lIns="0" tIns="0" rIns="0" bIns="0" rtlCol="0" anchor="ctr"/>
           <a:lstStyle/>
           <a:p>
-            <a:pPr indent="0" marL="0">
+            <a:pPr marL="0" indent="0">
               <a:buNone/>
             </a:pPr>
             <a:r>
@@ -4841,7 +4585,7 @@
             <a:endParaRPr lang="en-US" sz="3800" dirty="0"/>
           </a:p>
           <a:p>
-            <a:pPr indent="0" marL="0">
+            <a:pPr marL="0" indent="0">
               <a:buNone/>
             </a:pPr>
             <a:r>
@@ -4880,7 +4624,7 @@
           <a:bodyPr wrap="square" lIns="0" tIns="0" rIns="0" bIns="0" rtlCol="0" anchor="ctr"/>
           <a:lstStyle/>
           <a:p>
-            <a:pPr indent="0" marL="0">
+            <a:pPr marL="0" indent="0">
               <a:buNone/>
             </a:pPr>
             <a:r>
@@ -4946,7 +4690,7 @@
           <a:bodyPr wrap="square" lIns="0" tIns="0" rIns="0" bIns="0" rtlCol="0" anchor="ctr"/>
           <a:lstStyle/>
           <a:p>
-            <a:pPr algn="ctr" indent="0" marL="0">
+            <a:pPr marL="0" indent="0" algn="ctr">
               <a:buNone/>
             </a:pPr>
             <a:r>
@@ -4985,7 +4729,7 @@
           <a:bodyPr wrap="square" lIns="0" tIns="0" rIns="0" bIns="0" rtlCol="0" anchor="ctr"/>
           <a:lstStyle/>
           <a:p>
-            <a:pPr algn="ctr" indent="0" marL="0">
+            <a:pPr marL="0" indent="0" algn="ctr">
               <a:buNone/>
             </a:pPr>
             <a:r>
@@ -5051,7 +4795,7 @@
           <a:bodyPr wrap="square" lIns="0" tIns="0" rIns="0" bIns="0" rtlCol="0" anchor="ctr"/>
           <a:lstStyle/>
           <a:p>
-            <a:pPr algn="ctr" indent="0" marL="0">
+            <a:pPr marL="0" indent="0" algn="ctr">
               <a:buNone/>
             </a:pPr>
             <a:r>
@@ -5090,7 +4834,7 @@
           <a:bodyPr wrap="square" lIns="0" tIns="0" rIns="0" bIns="0" rtlCol="0" anchor="ctr"/>
           <a:lstStyle/>
           <a:p>
-            <a:pPr algn="ctr" indent="0" marL="0">
+            <a:pPr marL="0" indent="0" algn="ctr">
               <a:buNone/>
             </a:pPr>
             <a:r>
@@ -5156,7 +4900,7 @@
           <a:bodyPr wrap="square" lIns="0" tIns="0" rIns="0" bIns="0" rtlCol="0" anchor="ctr"/>
           <a:lstStyle/>
           <a:p>
-            <a:pPr algn="ctr" indent="0" marL="0">
+            <a:pPr marL="0" indent="0" algn="ctr">
               <a:buNone/>
             </a:pPr>
             <a:r>
@@ -5195,7 +4939,7 @@
           <a:bodyPr wrap="square" lIns="0" tIns="0" rIns="0" bIns="0" rtlCol="0" anchor="ctr"/>
           <a:lstStyle/>
           <a:p>
-            <a:pPr algn="ctr" indent="0" marL="0">
+            <a:pPr marL="0" indent="0" algn="ctr">
               <a:buNone/>
             </a:pPr>
             <a:r>
@@ -5261,7 +5005,7 @@
           <a:bodyPr wrap="square" lIns="0" tIns="0" rIns="0" bIns="0" rtlCol="0" anchor="ctr"/>
           <a:lstStyle/>
           <a:p>
-            <a:pPr algn="ctr" indent="0" marL="0">
+            <a:pPr marL="0" indent="0" algn="ctr">
               <a:buNone/>
             </a:pPr>
             <a:r>
@@ -5300,7 +5044,7 @@
           <a:bodyPr wrap="square" lIns="0" tIns="0" rIns="0" bIns="0" rtlCol="0" anchor="ctr"/>
           <a:lstStyle/>
           <a:p>
-            <a:pPr algn="ctr" indent="0" marL="0">
+            <a:pPr marL="0" indent="0" algn="ctr">
               <a:buNone/>
             </a:pPr>
             <a:r>
@@ -5324,7 +5068,7 @@
     <a:masterClrMapping/>
   </p:clrMapOvr>
   <p:transition spd="slow">
-    <p:push dir="l"/>
+    <p:push/>
   </p:transition>
 </p:sld>
 </file>
@@ -5337,6 +5081,7 @@
         <a:solidFill>
           <a:srgbClr val="FFFFFF"/>
         </a:solidFill>
+        <a:effectLst/>
       </p:bgPr>
     </p:bg>
     <p:spTree>
@@ -5374,11 +5119,11 @@
           <a:bodyPr wrap="square" lIns="0" tIns="0" rIns="0" bIns="0" rtlCol="0" anchor="ctr"/>
           <a:lstStyle/>
           <a:p>
-            <a:pPr indent="0" marL="0">
-              <a:buNone/>
-            </a:pPr>
-            <a:r>
-              <a:rPr lang="en-US" sz="1200" b="1" spc="300" kern="0" dirty="0">
+            <a:pPr marL="0" indent="0">
+              <a:buNone/>
+            </a:pPr>
+            <a:r>
+              <a:rPr lang="en-US" sz="1200" b="1" kern="0" spc="300" dirty="0">
                 <a:solidFill>
                   <a:srgbClr val="1B6FC2"/>
                 </a:solidFill>
@@ -5413,7 +5158,7 @@
           <a:bodyPr wrap="square" lIns="0" tIns="0" rIns="0" bIns="0" rtlCol="0" anchor="ctr"/>
           <a:lstStyle/>
           <a:p>
-            <a:pPr indent="0" marL="0">
+            <a:pPr marL="0" indent="0">
               <a:buNone/>
             </a:pPr>
             <a:r>
@@ -5433,14 +5178,14 @@
       </p:sp>
       <p:pic>
         <p:nvPicPr>
-          <p:cNvPr id="4" name="Image 0" descr="C:\Users\shamo\OneDrive - United Nations\UN-DCO\10 — Innovation Sanbox\The Grassroots\docs\screenshots\02-map-overview.png">    </p:cNvPr>
+          <p:cNvPr id="4" name="Image 0" descr="C:\Users\shamo\OneDrive - United Nations\UN-DCO\10 — Innovation Sanbox\The Grassroots\docs\screenshots\02-map-overview.png"/>
           <p:cNvPicPr>
             <a:picLocks noChangeAspect="1"/>
           </p:cNvPicPr>
           <p:nvPr/>
         </p:nvPicPr>
         <p:blipFill>
-          <a:blip r:embed="rId1"/>
+          <a:blip r:embed="rId3"/>
           <a:stretch>
             <a:fillRect/>
           </a:stretch>
@@ -5503,11 +5248,11 @@
           <a:bodyPr wrap="square" lIns="0" tIns="0" rIns="0" bIns="0" rtlCol="0" anchor="ctr"/>
           <a:lstStyle/>
           <a:p>
-            <a:pPr algn="ctr" indent="0" marL="0">
-              <a:buNone/>
-            </a:pPr>
-            <a:r>
-              <a:rPr lang="en-US" sz="1000" b="1" spc="200" kern="0" dirty="0">
+            <a:pPr marL="0" indent="0" algn="ctr">
+              <a:buNone/>
+            </a:pPr>
+            <a:r>
+              <a:rPr lang="en-US" sz="1000" b="1" kern="0" spc="200" dirty="0">
                 <a:solidFill>
                   <a:srgbClr val="A8760F"/>
                 </a:solidFill>
@@ -5548,14 +5293,14 @@
       </p:sp>
       <p:pic>
         <p:nvPicPr>
-          <p:cNvPr id="8" name="Image 1" descr="C:\Users\shamo\AppData\Local\Temp\claude\C--Users-shamo-OneDrive---United-Nations-UN-DCO-10---Innovation-Sanbox-The-Grassroots\0eee3bdb-6389-4071-99a7-070b782b3283\scratchpad\iconpng\globeBlue.png">    </p:cNvPr>
+          <p:cNvPr id="8" name="Image 1" descr="C:\Users\shamo\AppData\Local\Temp\claude\C--Users-shamo-OneDrive---United-Nations-UN-DCO-10---Innovation-Sanbox-The-Grassroots\0eee3bdb-6389-4071-99a7-070b782b3283\scratchpad\iconpng\globeBlue.png"/>
           <p:cNvPicPr>
             <a:picLocks noChangeAspect="1"/>
           </p:cNvPicPr>
           <p:nvPr/>
         </p:nvPicPr>
         <p:blipFill>
-          <a:blip r:embed="rId2"/>
+          <a:blip r:embed="rId4"/>
           <a:stretch>
             <a:fillRect/>
           </a:stretch>
@@ -5591,7 +5336,7 @@
           <a:bodyPr wrap="square" lIns="0" tIns="0" rIns="0" bIns="0" rtlCol="0" anchor="t"/>
           <a:lstStyle/>
           <a:p>
-            <a:pPr indent="0" marL="0">
+            <a:pPr marL="0" indent="0">
               <a:buNone/>
             </a:pPr>
             <a:r>
@@ -5636,14 +5381,14 @@
       </p:sp>
       <p:pic>
         <p:nvPicPr>
-          <p:cNvPr id="11" name="Image 2" descr="C:\Users\shamo\AppData\Local\Temp\claude\C--Users-shamo-OneDrive---United-Nations-UN-DCO-10---Innovation-Sanbox-The-Grassroots\0eee3bdb-6389-4071-99a7-070b782b3283\scratchpad\iconpng\chart.png">    </p:cNvPr>
+          <p:cNvPr id="11" name="Image 2" descr="C:\Users\shamo\AppData\Local\Temp\claude\C--Users-shamo-OneDrive---United-Nations-UN-DCO-10---Innovation-Sanbox-The-Grassroots\0eee3bdb-6389-4071-99a7-070b782b3283\scratchpad\iconpng\chart.png"/>
           <p:cNvPicPr>
             <a:picLocks noChangeAspect="1"/>
           </p:cNvPicPr>
           <p:nvPr/>
         </p:nvPicPr>
         <p:blipFill>
-          <a:blip r:embed="rId3"/>
+          <a:blip r:embed="rId5"/>
           <a:stretch>
             <a:fillRect/>
           </a:stretch>
@@ -5679,7 +5424,7 @@
           <a:bodyPr wrap="square" lIns="0" tIns="0" rIns="0" bIns="0" rtlCol="0" anchor="t"/>
           <a:lstStyle/>
           <a:p>
-            <a:pPr indent="0" marL="0">
+            <a:pPr marL="0" indent="0">
               <a:buNone/>
             </a:pPr>
             <a:r>
@@ -5724,14 +5469,14 @@
       </p:sp>
       <p:pic>
         <p:nvPicPr>
-          <p:cNvPr id="14" name="Image 3" descr="C:\Users\shamo\AppData\Local\Temp\claude\C--Users-shamo-OneDrive---United-Nations-UN-DCO-10---Innovation-Sanbox-The-Grassroots\0eee3bdb-6389-4071-99a7-070b782b3283\scratchpad\iconpng\binoculars.png">    </p:cNvPr>
+          <p:cNvPr id="14" name="Image 3" descr="C:\Users\shamo\AppData\Local\Temp\claude\C--Users-shamo-OneDrive---United-Nations-UN-DCO-10---Innovation-Sanbox-The-Grassroots\0eee3bdb-6389-4071-99a7-070b782b3283\scratchpad\iconpng\binoculars.png"/>
           <p:cNvPicPr>
             <a:picLocks noChangeAspect="1"/>
           </p:cNvPicPr>
           <p:nvPr/>
         </p:nvPicPr>
         <p:blipFill>
-          <a:blip r:embed="rId4"/>
+          <a:blip r:embed="rId6"/>
           <a:stretch>
             <a:fillRect/>
           </a:stretch>
@@ -5767,7 +5512,7 @@
           <a:bodyPr wrap="square" lIns="0" tIns="0" rIns="0" bIns="0" rtlCol="0" anchor="t"/>
           <a:lstStyle/>
           <a:p>
-            <a:pPr indent="0" marL="0">
+            <a:pPr marL="0" indent="0">
               <a:buNone/>
             </a:pPr>
             <a:r>
@@ -5806,7 +5551,7 @@
           <a:bodyPr wrap="square" lIns="0" tIns="0" rIns="0" bIns="0" rtlCol="0" anchor="ctr"/>
           <a:lstStyle/>
           <a:p>
-            <a:pPr indent="0" marL="0">
+            <a:pPr marL="0" indent="0">
               <a:buNone/>
             </a:pPr>
             <a:r>
@@ -5843,6 +5588,7 @@
         <a:solidFill>
           <a:srgbClr val="FFFFFF"/>
         </a:solidFill>
+        <a:effectLst/>
       </p:bgPr>
     </p:bg>
     <p:spTree>
@@ -5880,11 +5626,11 @@
           <a:bodyPr wrap="square" lIns="0" tIns="0" rIns="0" bIns="0" rtlCol="0" anchor="ctr"/>
           <a:lstStyle/>
           <a:p>
-            <a:pPr indent="0" marL="0">
-              <a:buNone/>
-            </a:pPr>
-            <a:r>
-              <a:rPr lang="en-US" sz="1200" b="1" spc="300" kern="0" dirty="0">
+            <a:pPr marL="0" indent="0">
+              <a:buNone/>
+            </a:pPr>
+            <a:r>
+              <a:rPr lang="en-US" sz="1200" b="1" kern="0" spc="300" dirty="0">
                 <a:solidFill>
                   <a:srgbClr val="1B6FC2"/>
                 </a:solidFill>
@@ -5919,7 +5665,7 @@
           <a:bodyPr wrap="square" lIns="0" tIns="0" rIns="0" bIns="0" rtlCol="0" anchor="ctr"/>
           <a:lstStyle/>
           <a:p>
-            <a:pPr indent="0" marL="0">
+            <a:pPr marL="0" indent="0">
               <a:buNone/>
             </a:pPr>
             <a:r>
@@ -5958,7 +5704,7 @@
           <a:bodyPr wrap="square" lIns="0" tIns="0" rIns="0" bIns="0" rtlCol="0" anchor="ctr"/>
           <a:lstStyle/>
           <a:p>
-            <a:pPr indent="0" marL="0">
+            <a:pPr marL="0" indent="0">
               <a:buNone/>
             </a:pPr>
             <a:r>
@@ -6049,7 +5795,7 @@
           <a:bodyPr wrap="square" lIns="0" tIns="0" rIns="0" bIns="0" rtlCol="0" anchor="ctr"/>
           <a:lstStyle/>
           <a:p>
-            <a:pPr indent="0" marL="0">
+            <a:pPr marL="0" indent="0">
               <a:buNone/>
             </a:pPr>
             <a:r>
@@ -6088,7 +5834,7 @@
           <a:bodyPr wrap="square" lIns="0" tIns="0" rIns="0" bIns="0" rtlCol="0" anchor="t"/>
           <a:lstStyle/>
           <a:p>
-            <a:pPr indent="0" marL="0">
+            <a:pPr marL="0" indent="0">
               <a:buNone/>
             </a:pPr>
             <a:r>
@@ -6179,7 +5925,7 @@
           <a:bodyPr wrap="square" lIns="0" tIns="0" rIns="0" bIns="0" rtlCol="0" anchor="ctr"/>
           <a:lstStyle/>
           <a:p>
-            <a:pPr indent="0" marL="0">
+            <a:pPr marL="0" indent="0">
               <a:buNone/>
             </a:pPr>
             <a:r>
@@ -6218,7 +5964,7 @@
           <a:bodyPr wrap="square" lIns="0" tIns="0" rIns="0" bIns="0" rtlCol="0" anchor="t"/>
           <a:lstStyle/>
           <a:p>
-            <a:pPr indent="0" marL="0">
+            <a:pPr marL="0" indent="0">
               <a:buNone/>
             </a:pPr>
             <a:r>
@@ -6309,7 +6055,7 @@
           <a:bodyPr wrap="square" lIns="0" tIns="0" rIns="0" bIns="0" rtlCol="0" anchor="ctr"/>
           <a:lstStyle/>
           <a:p>
-            <a:pPr indent="0" marL="0">
+            <a:pPr marL="0" indent="0">
               <a:buNone/>
             </a:pPr>
             <a:r>
@@ -6348,7 +6094,7 @@
           <a:bodyPr wrap="square" lIns="0" tIns="0" rIns="0" bIns="0" rtlCol="0" anchor="t"/>
           <a:lstStyle/>
           <a:p>
-            <a:pPr indent="0" marL="0">
+            <a:pPr marL="0" indent="0">
               <a:buNone/>
             </a:pPr>
             <a:r>
@@ -6439,7 +6185,7 @@
           <a:bodyPr wrap="square" lIns="0" tIns="0" rIns="0" bIns="0" rtlCol="0" anchor="ctr"/>
           <a:lstStyle/>
           <a:p>
-            <a:pPr indent="0" marL="0">
+            <a:pPr marL="0" indent="0">
               <a:buNone/>
             </a:pPr>
             <a:r>
@@ -6478,7 +6224,7 @@
           <a:bodyPr wrap="square" lIns="0" tIns="0" rIns="0" bIns="0" rtlCol="0" anchor="t"/>
           <a:lstStyle/>
           <a:p>
-            <a:pPr indent="0" marL="0">
+            <a:pPr marL="0" indent="0">
               <a:buNone/>
             </a:pPr>
             <a:r>
@@ -6525,14 +6271,14 @@
       </p:sp>
       <p:pic>
         <p:nvPicPr>
-          <p:cNvPr id="22" name="Image 0" descr="C:\Users\shamo\AppData\Local\Temp\claude\C--Users-shamo-OneDrive---United-Nations-UN-DCO-10---Innovation-Sanbox-The-Grassroots\0eee3bdb-6389-4071-99a7-070b782b3283\scratchpad\iconpng\bolt.png">    </p:cNvPr>
+          <p:cNvPr id="22" name="Image 0" descr="C:\Users\shamo\AppData\Local\Temp\claude\C--Users-shamo-OneDrive---United-Nations-UN-DCO-10---Innovation-Sanbox-The-Grassroots\0eee3bdb-6389-4071-99a7-070b782b3283\scratchpad\iconpng\bolt.png"/>
           <p:cNvPicPr>
             <a:picLocks noChangeAspect="1"/>
           </p:cNvPicPr>
           <p:nvPr/>
         </p:nvPicPr>
         <p:blipFill>
-          <a:blip r:embed="rId1"/>
+          <a:blip r:embed="rId3"/>
           <a:stretch>
             <a:fillRect/>
           </a:stretch>
@@ -6568,7 +6314,7 @@
           <a:bodyPr wrap="square" lIns="0" tIns="0" rIns="0" bIns="0" rtlCol="0" anchor="ctr"/>
           <a:lstStyle/>
           <a:p>
-            <a:pPr indent="0" marL="0">
+            <a:pPr marL="0" indent="0">
               <a:buNone/>
             </a:pPr>
             <a:r>
@@ -6582,9 +6328,6 @@
               </a:rPr>
               <a:t>The clock is part of the answer.  </a:t>
             </a:r>
-            <a:pPr indent="0" marL="0">
-              <a:buNone/>
-            </a:pPr>
             <a:r>
               <a:rPr lang="en-US" sz="1350" dirty="0">
                 <a:solidFill>
@@ -6619,6 +6362,7 @@
         <a:solidFill>
           <a:srgbClr val="FFFFFF"/>
         </a:solidFill>
+        <a:effectLst/>
       </p:bgPr>
     </p:bg>
     <p:spTree>
@@ -6656,11 +6400,11 @@
           <a:bodyPr wrap="square" lIns="0" tIns="0" rIns="0" bIns="0" rtlCol="0" anchor="ctr"/>
           <a:lstStyle/>
           <a:p>
-            <a:pPr indent="0" marL="0">
-              <a:buNone/>
-            </a:pPr>
-            <a:r>
-              <a:rPr lang="en-US" sz="1200" b="1" spc="300" kern="0" dirty="0">
+            <a:pPr marL="0" indent="0">
+              <a:buNone/>
+            </a:pPr>
+            <a:r>
+              <a:rPr lang="en-US" sz="1200" b="1" kern="0" spc="300" dirty="0">
                 <a:solidFill>
                   <a:srgbClr val="1B6FC2"/>
                 </a:solidFill>
@@ -6695,7 +6439,7 @@
           <a:bodyPr wrap="square" lIns="0" tIns="0" rIns="0" bIns="0" rtlCol="0" anchor="ctr"/>
           <a:lstStyle/>
           <a:p>
-            <a:pPr indent="0" marL="0">
+            <a:pPr marL="0" indent="0">
               <a:buNone/>
             </a:pPr>
             <a:r>
@@ -6715,14 +6459,14 @@
       </p:sp>
       <p:pic>
         <p:nvPicPr>
-          <p:cNvPr id="4" name="Image 0" descr="C:\Users\shamo\OneDrive - United Nations\UN-DCO\10 — Innovation Sanbox\The Grassroots\docs\screenshots\07-project-primary-kpis.png">    </p:cNvPr>
+          <p:cNvPr id="4" name="Image 0" descr="C:\Users\shamo\OneDrive - United Nations\UN-DCO\10 — Innovation Sanbox\The Grassroots\docs\screenshots\07-project-primary-kpis.png"/>
           <p:cNvPicPr>
             <a:picLocks noChangeAspect="1"/>
           </p:cNvPicPr>
           <p:nvPr/>
         </p:nvPicPr>
         <p:blipFill>
-          <a:blip r:embed="rId1"/>
+          <a:blip r:embed="rId3"/>
           <a:stretch>
             <a:fillRect/>
           </a:stretch>
@@ -6785,11 +6529,11 @@
           <a:bodyPr wrap="square" lIns="0" tIns="0" rIns="0" bIns="0" rtlCol="0" anchor="ctr"/>
           <a:lstStyle/>
           <a:p>
-            <a:pPr algn="ctr" indent="0" marL="0">
-              <a:buNone/>
-            </a:pPr>
-            <a:r>
-              <a:rPr lang="en-US" sz="1000" b="1" spc="200" kern="0" dirty="0">
+            <a:pPr marL="0" indent="0" algn="ctr">
+              <a:buNone/>
+            </a:pPr>
+            <a:r>
+              <a:rPr lang="en-US" sz="1000" b="1" kern="0" spc="200" dirty="0">
                 <a:solidFill>
                   <a:srgbClr val="A8760F"/>
                 </a:solidFill>
@@ -6824,7 +6568,7 @@
           <a:bodyPr wrap="square" lIns="0" tIns="0" rIns="0" bIns="0" rtlCol="0" anchor="t"/>
           <a:lstStyle/>
           <a:p>
-            <a:pPr indent="0" marL="0">
+            <a:pPr marL="0" indent="0">
               <a:buNone/>
             </a:pPr>
             <a:r>
@@ -6839,9 +6583,6 @@
               <a:t>Every project shows its funder, its budget, its dates — and the results it signed up to deliver.
 </a:t>
             </a:r>
-            <a:pPr indent="0" marL="0">
-              <a:buNone/>
-            </a:pPr>
             <a:r>
               <a:rPr lang="en-US" sz="1350" dirty="0">
                 <a:solidFill>
@@ -6852,21 +6593,7 @@
                 <a:cs typeface="Calibri" pitchFamily="34" charset="-120"/>
               </a:rPr>
               <a:t>When a funder asks "what did our contribution achieve?", the answer is already on screen: their projects, their communities, their outcomes — filtered in one click.
-</a:t>
-            </a:r>
-            <a:pPr indent="0" marL="0">
-              <a:buNone/>
-            </a:pPr>
-            <a:r>
-              <a:rPr lang="en-US" sz="1350" dirty="0">
-                <a:solidFill>
-                  <a:srgbClr val="5B6B7E"/>
-                </a:solidFill>
-                <a:latin typeface="Calibri" pitchFamily="34" charset="0"/>
-                <a:ea typeface="Calibri" pitchFamily="34" charset="-122"/>
-                <a:cs typeface="Calibri" pitchFamily="34" charset="-120"/>
-              </a:rPr>
-              <a:t>No scrambling before the donor meeting. No reconciling three spreadsheets that disagree.</a:t>
+No scrambling before the donor meeting. No reconciling three spreadsheets that disagree.</a:t>
             </a:r>
             <a:endParaRPr lang="en-US" sz="1350" dirty="0"/>
           </a:p>
@@ -6893,7 +6620,7 @@
           <a:bodyPr wrap="square" lIns="0" tIns="0" rIns="0" bIns="0" rtlCol="0" anchor="ctr"/>
           <a:lstStyle/>
           <a:p>
-            <a:pPr indent="0" marL="0">
+            <a:pPr marL="0" indent="0">
               <a:buNone/>
             </a:pPr>
             <a:r>
@@ -6930,6 +6657,7 @@
         <a:solidFill>
           <a:srgbClr val="0E2A47"/>
         </a:solidFill>
+        <a:effectLst/>
       </p:bgPr>
     </p:bg>
     <p:spTree>
@@ -7021,11 +6749,11 @@
           <a:bodyPr wrap="square" lIns="0" tIns="0" rIns="0" bIns="0" rtlCol="0" anchor="ctr"/>
           <a:lstStyle/>
           <a:p>
-            <a:pPr indent="0" marL="0">
-              <a:buNone/>
-            </a:pPr>
-            <a:r>
-              <a:rPr lang="en-US" sz="1200" b="1" spc="300" kern="0" dirty="0">
+            <a:pPr marL="0" indent="0">
+              <a:buNone/>
+            </a:pPr>
+            <a:r>
+              <a:rPr lang="en-US" sz="1200" b="1" kern="0" spc="300" dirty="0">
                 <a:solidFill>
                   <a:srgbClr val="F5B942"/>
                 </a:solidFill>
@@ -7060,7 +6788,7 @@
           <a:bodyPr wrap="square" lIns="0" tIns="0" rIns="0" bIns="0" rtlCol="0" anchor="ctr"/>
           <a:lstStyle/>
           <a:p>
-            <a:pPr indent="0" marL="0">
+            <a:pPr marL="0" indent="0">
               <a:buNone/>
             </a:pPr>
             <a:r>
@@ -7077,7 +6805,7 @@
             <a:endParaRPr lang="en-US" sz="3800" dirty="0"/>
           </a:p>
           <a:p>
-            <a:pPr indent="0" marL="0">
+            <a:pPr marL="0" indent="0">
               <a:buNone/>
             </a:pPr>
             <a:r>
@@ -7149,14 +6877,14 @@
       </p:sp>
       <p:pic>
         <p:nvPicPr>
-          <p:cNvPr id="8" name="Image 0" descr="C:\Users\shamo\AppData\Local\Temp\claude\C--Users-shamo-OneDrive---United-Nations-UN-DCO-10---Innovation-Sanbox-The-Grassroots\0eee3bdb-6389-4071-99a7-070b782b3283\scratchpad\iconpng\checkWhite.png">    </p:cNvPr>
+          <p:cNvPr id="8" name="Image 0" descr="C:\Users\shamo\AppData\Local\Temp\claude\C--Users-shamo-OneDrive---United-Nations-UN-DCO-10---Innovation-Sanbox-The-Grassroots\0eee3bdb-6389-4071-99a7-070b782b3283\scratchpad\iconpng\checkWhite.png"/>
           <p:cNvPicPr>
             <a:picLocks noChangeAspect="1"/>
           </p:cNvPicPr>
           <p:nvPr/>
         </p:nvPicPr>
         <p:blipFill>
-          <a:blip r:embed="rId1"/>
+          <a:blip r:embed="rId3"/>
           <a:stretch>
             <a:fillRect/>
           </a:stretch>
@@ -7192,7 +6920,7 @@
           <a:bodyPr wrap="square" lIns="0" tIns="0" rIns="0" bIns="0" rtlCol="0" anchor="ctr"/>
           <a:lstStyle/>
           <a:p>
-            <a:pPr indent="0" marL="0">
+            <a:pPr marL="0" indent="0">
               <a:buNone/>
             </a:pPr>
             <a:r>
@@ -7231,7 +6959,7 @@
           <a:bodyPr wrap="square" lIns="0" tIns="0" rIns="0" bIns="0" rtlCol="0" anchor="t"/>
           <a:lstStyle/>
           <a:p>
-            <a:pPr indent="0" marL="0">
+            <a:pPr marL="0" indent="0">
               <a:buNone/>
             </a:pPr>
             <a:r>
@@ -7303,14 +7031,14 @@
       </p:sp>
       <p:pic>
         <p:nvPicPr>
-          <p:cNvPr id="13" name="Image 1" descr="C:\Users\shamo\AppData\Local\Temp\claude\C--Users-shamo-OneDrive---United-Nations-UN-DCO-10---Innovation-Sanbox-The-Grassroots\0eee3bdb-6389-4071-99a7-070b782b3283\scratchpad\iconpng\pinWhite.png">    </p:cNvPr>
+          <p:cNvPr id="13" name="Image 1" descr="C:\Users\shamo\AppData\Local\Temp\claude\C--Users-shamo-OneDrive---United-Nations-UN-DCO-10---Innovation-Sanbox-The-Grassroots\0eee3bdb-6389-4071-99a7-070b782b3283\scratchpad\iconpng\pinWhite.png"/>
           <p:cNvPicPr>
             <a:picLocks noChangeAspect="1"/>
           </p:cNvPicPr>
           <p:nvPr/>
         </p:nvPicPr>
         <p:blipFill>
-          <a:blip r:embed="rId2"/>
+          <a:blip r:embed="rId4"/>
           <a:stretch>
             <a:fillRect/>
           </a:stretch>
@@ -7346,7 +7074,7 @@
           <a:bodyPr wrap="square" lIns="0" tIns="0" rIns="0" bIns="0" rtlCol="0" anchor="ctr"/>
           <a:lstStyle/>
           <a:p>
-            <a:pPr indent="0" marL="0">
+            <a:pPr marL="0" indent="0">
               <a:buNone/>
             </a:pPr>
             <a:r>
@@ -7385,7 +7113,7 @@
           <a:bodyPr wrap="square" lIns="0" tIns="0" rIns="0" bIns="0" rtlCol="0" anchor="t"/>
           <a:lstStyle/>
           <a:p>
-            <a:pPr indent="0" marL="0">
+            <a:pPr marL="0" indent="0">
               <a:buNone/>
             </a:pPr>
             <a:r>
@@ -7457,14 +7185,14 @@
       </p:sp>
       <p:pic>
         <p:nvPicPr>
-          <p:cNvPr id="18" name="Image 2" descr="C:\Users\shamo\AppData\Local\Temp\claude\C--Users-shamo-OneDrive---United-Nations-UN-DCO-10---Innovation-Sanbox-The-Grassroots\0eee3bdb-6389-4071-99a7-070b782b3283\scratchpad\iconpng\usersWhite.png">    </p:cNvPr>
+          <p:cNvPr id="18" name="Image 2" descr="C:\Users\shamo\AppData\Local\Temp\claude\C--Users-shamo-OneDrive---United-Nations-UN-DCO-10---Innovation-Sanbox-The-Grassroots\0eee3bdb-6389-4071-99a7-070b782b3283\scratchpad\iconpng\usersWhite.png"/>
           <p:cNvPicPr>
             <a:picLocks noChangeAspect="1"/>
           </p:cNvPicPr>
           <p:nvPr/>
         </p:nvPicPr>
         <p:blipFill>
-          <a:blip r:embed="rId3"/>
+          <a:blip r:embed="rId5"/>
           <a:stretch>
             <a:fillRect/>
           </a:stretch>
@@ -7500,7 +7228,7 @@
           <a:bodyPr wrap="square" lIns="0" tIns="0" rIns="0" bIns="0" rtlCol="0" anchor="ctr"/>
           <a:lstStyle/>
           <a:p>
-            <a:pPr indent="0" marL="0">
+            <a:pPr marL="0" indent="0">
               <a:buNone/>
             </a:pPr>
             <a:r>
@@ -7539,7 +7267,7 @@
           <a:bodyPr wrap="square" lIns="0" tIns="0" rIns="0" bIns="0" rtlCol="0" anchor="t"/>
           <a:lstStyle/>
           <a:p>
-            <a:pPr indent="0" marL="0">
+            <a:pPr marL="0" indent="0">
               <a:buNone/>
             </a:pPr>
             <a:r>
@@ -7578,7 +7306,7 @@
           <a:bodyPr wrap="square" lIns="0" tIns="0" rIns="0" bIns="0" rtlCol="0" anchor="ctr"/>
           <a:lstStyle/>
           <a:p>
-            <a:pPr algn="ctr" indent="0" marL="0">
+            <a:pPr marL="0" indent="0" algn="ctr">
               <a:buNone/>
             </a:pPr>
             <a:r>
@@ -7602,7 +7330,7 @@
     <a:masterClrMapping/>
   </p:clrMapOvr>
   <p:transition spd="slow">
-    <p:push dir="l"/>
+    <p:push/>
   </p:transition>
 </p:sld>
 </file>
@@ -7615,6 +7343,7 @@
         <a:solidFill>
           <a:srgbClr val="FFFFFF"/>
         </a:solidFill>
+        <a:effectLst/>
       </p:bgPr>
     </p:bg>
     <p:spTree>
@@ -7652,11 +7381,11 @@
           <a:bodyPr wrap="square" lIns="0" tIns="0" rIns="0" bIns="0" rtlCol="0" anchor="ctr"/>
           <a:lstStyle/>
           <a:p>
-            <a:pPr indent="0" marL="0">
-              <a:buNone/>
-            </a:pPr>
-            <a:r>
-              <a:rPr lang="en-US" sz="1200" b="1" spc="300" kern="0" dirty="0">
+            <a:pPr marL="0" indent="0">
+              <a:buNone/>
+            </a:pPr>
+            <a:r>
+              <a:rPr lang="en-US" sz="1200" b="1" kern="0" spc="300" dirty="0">
                 <a:solidFill>
                   <a:srgbClr val="1B6FC2"/>
                 </a:solidFill>
@@ -7691,7 +7420,7 @@
           <a:bodyPr wrap="square" lIns="0" tIns="0" rIns="0" bIns="0" rtlCol="0" anchor="ctr"/>
           <a:lstStyle/>
           <a:p>
-            <a:pPr indent="0" marL="0">
+            <a:pPr marL="0" indent="0">
               <a:buNone/>
             </a:pPr>
             <a:r>
@@ -7730,7 +7459,7 @@
           <a:bodyPr wrap="square" lIns="0" tIns="0" rIns="0" bIns="0" rtlCol="0" anchor="ctr"/>
           <a:lstStyle/>
           <a:p>
-            <a:pPr indent="0" marL="0">
+            <a:pPr marL="0" indent="0">
               <a:buNone/>
             </a:pPr>
             <a:r>
@@ -7802,14 +7531,14 @@
       </p:sp>
       <p:pic>
         <p:nvPicPr>
-          <p:cNvPr id="7" name="Image 0" descr="C:\Users\shamo\AppData\Local\Temp\claude\C--Users-shamo-OneDrive---United-Nations-UN-DCO-10---Innovation-Sanbox-The-Grassroots\0eee3bdb-6389-4071-99a7-070b782b3283\scratchpad\iconpng\female.png">    </p:cNvPr>
+          <p:cNvPr id="7" name="Image 0" descr="C:\Users\shamo\AppData\Local\Temp\claude\C--Users-shamo-OneDrive---United-Nations-UN-DCO-10---Innovation-Sanbox-The-Grassroots\0eee3bdb-6389-4071-99a7-070b782b3283\scratchpad\iconpng\female.png"/>
           <p:cNvPicPr>
             <a:picLocks noChangeAspect="1"/>
           </p:cNvPicPr>
           <p:nvPr/>
         </p:nvPicPr>
         <p:blipFill>
-          <a:blip r:embed="rId1"/>
+          <a:blip r:embed="rId3"/>
           <a:stretch>
             <a:fillRect/>
           </a:stretch>
@@ -7845,7 +7574,7 @@
           <a:bodyPr wrap="square" lIns="0" tIns="0" rIns="0" bIns="0" rtlCol="0" anchor="t"/>
           <a:lstStyle/>
           <a:p>
-            <a:pPr algn="ctr" indent="0" marL="0">
+            <a:pPr marL="0" indent="0" algn="ctr">
               <a:buNone/>
             </a:pPr>
             <a:r>
@@ -7917,14 +7646,14 @@
       </p:sp>
       <p:pic>
         <p:nvPicPr>
-          <p:cNvPr id="11" name="Image 1" descr="C:\Users\shamo\AppData\Local\Temp\claude\C--Users-shamo-OneDrive---United-Nations-UN-DCO-10---Innovation-Sanbox-The-Grassroots\0eee3bdb-6389-4071-99a7-070b782b3283\scratchpad\iconpng\child.png">    </p:cNvPr>
+          <p:cNvPr id="11" name="Image 1" descr="C:\Users\shamo\AppData\Local\Temp\claude\C--Users-shamo-OneDrive---United-Nations-UN-DCO-10---Innovation-Sanbox-The-Grassroots\0eee3bdb-6389-4071-99a7-070b782b3283\scratchpad\iconpng\child.png"/>
           <p:cNvPicPr>
             <a:picLocks noChangeAspect="1"/>
           </p:cNvPicPr>
           <p:nvPr/>
         </p:nvPicPr>
         <p:blipFill>
-          <a:blip r:embed="rId2"/>
+          <a:blip r:embed="rId4"/>
           <a:stretch>
             <a:fillRect/>
           </a:stretch>
@@ -7960,7 +7689,7 @@
           <a:bodyPr wrap="square" lIns="0" tIns="0" rIns="0" bIns="0" rtlCol="0" anchor="t"/>
           <a:lstStyle/>
           <a:p>
-            <a:pPr algn="ctr" indent="0" marL="0">
+            <a:pPr marL="0" indent="0" algn="ctr">
               <a:buNone/>
             </a:pPr>
             <a:r>
@@ -8032,14 +7761,14 @@
       </p:sp>
       <p:pic>
         <p:nvPicPr>
-          <p:cNvPr id="15" name="Image 2" descr="C:\Users\shamo\AppData\Local\Temp\claude\C--Users-shamo-OneDrive---United-Nations-UN-DCO-10---Innovation-Sanbox-The-Grassroots\0eee3bdb-6389-4071-99a7-070b782b3283\scratchpad\iconpng\wheelchair.png">    </p:cNvPr>
+          <p:cNvPr id="15" name="Image 2" descr="C:\Users\shamo\AppData\Local\Temp\claude\C--Users-shamo-OneDrive---United-Nations-UN-DCO-10---Innovation-Sanbox-The-Grassroots\0eee3bdb-6389-4071-99a7-070b782b3283\scratchpad\iconpng\wheelchair.png"/>
           <p:cNvPicPr>
             <a:picLocks noChangeAspect="1"/>
           </p:cNvPicPr>
           <p:nvPr/>
         </p:nvPicPr>
         <p:blipFill>
-          <a:blip r:embed="rId3"/>
+          <a:blip r:embed="rId5"/>
           <a:stretch>
             <a:fillRect/>
           </a:stretch>
@@ -8075,7 +7804,7 @@
           <a:bodyPr wrap="square" lIns="0" tIns="0" rIns="0" bIns="0" rtlCol="0" anchor="t"/>
           <a:lstStyle/>
           <a:p>
-            <a:pPr algn="ctr" indent="0" marL="0">
+            <a:pPr marL="0" indent="0" algn="ctr">
               <a:buNone/>
             </a:pPr>
             <a:r>
@@ -8147,14 +7876,14 @@
       </p:sp>
       <p:pic>
         <p:nvPicPr>
-          <p:cNvPr id="19" name="Image 3" descr="C:\Users\shamo\AppData\Local\Temp\claude\C--Users-shamo-OneDrive---United-Nations-UN-DCO-10---Innovation-Sanbox-The-Grassroots\0eee3bdb-6389-4071-99a7-070b782b3283\scratchpad\iconpng\home.png">    </p:cNvPr>
+          <p:cNvPr id="19" name="Image 3" descr="C:\Users\shamo\AppData\Local\Temp\claude\C--Users-shamo-OneDrive---United-Nations-UN-DCO-10---Innovation-Sanbox-The-Grassroots\0eee3bdb-6389-4071-99a7-070b782b3283\scratchpad\iconpng\home.png"/>
           <p:cNvPicPr>
             <a:picLocks noChangeAspect="1"/>
           </p:cNvPicPr>
           <p:nvPr/>
         </p:nvPicPr>
         <p:blipFill>
-          <a:blip r:embed="rId4"/>
+          <a:blip r:embed="rId6"/>
           <a:stretch>
             <a:fillRect/>
           </a:stretch>
@@ -8190,7 +7919,7 @@
           <a:bodyPr wrap="square" lIns="0" tIns="0" rIns="0" bIns="0" rtlCol="0" anchor="t"/>
           <a:lstStyle/>
           <a:p>
-            <a:pPr algn="ctr" indent="0" marL="0">
+            <a:pPr marL="0" indent="0" algn="ctr">
               <a:buNone/>
             </a:pPr>
             <a:r>
@@ -8237,14 +7966,14 @@
       </p:sp>
       <p:pic>
         <p:nvPicPr>
-          <p:cNvPr id="22" name="Image 4" descr="C:\Users\shamo\AppData\Local\Temp\claude\C--Users-shamo-OneDrive---United-Nations-UN-DCO-10---Innovation-Sanbox-The-Grassroots\0eee3bdb-6389-4071-99a7-070b782b3283\scratchpad\iconpng\heart.png">    </p:cNvPr>
+          <p:cNvPr id="22" name="Image 4" descr="C:\Users\shamo\AppData\Local\Temp\claude\C--Users-shamo-OneDrive---United-Nations-UN-DCO-10---Innovation-Sanbox-The-Grassroots\0eee3bdb-6389-4071-99a7-070b782b3283\scratchpad\iconpng\heart.png"/>
           <p:cNvPicPr>
             <a:picLocks noChangeAspect="1"/>
           </p:cNvPicPr>
           <p:nvPr/>
         </p:nvPicPr>
         <p:blipFill>
-          <a:blip r:embed="rId5"/>
+          <a:blip r:embed="rId7"/>
           <a:stretch>
             <a:fillRect/>
           </a:stretch>
@@ -8280,7 +8009,7 @@
           <a:bodyPr wrap="square" lIns="0" tIns="0" rIns="0" bIns="0" rtlCol="0" anchor="ctr"/>
           <a:lstStyle/>
           <a:p>
-            <a:pPr indent="0" marL="0">
+            <a:pPr marL="0" indent="0">
               <a:buNone/>
             </a:pPr>
             <a:r>
@@ -8294,9 +8023,6 @@
               </a:rPr>
               <a:t>Ask the hard question in one click:  </a:t>
             </a:r>
-            <a:pPr indent="0" marL="0">
-              <a:buNone/>
-            </a:pPr>
             <a:r>
               <a:rPr lang="en-US" sz="1350" dirty="0">
                 <a:solidFill>
@@ -8331,6 +8057,7 @@
         <a:solidFill>
           <a:srgbClr val="FFFFFF"/>
         </a:solidFill>
+        <a:effectLst/>
       </p:bgPr>
     </p:bg>
     <p:spTree>
@@ -8368,11 +8095,11 @@
           <a:bodyPr wrap="square" lIns="0" tIns="0" rIns="0" bIns="0" rtlCol="0" anchor="ctr"/>
           <a:lstStyle/>
           <a:p>
-            <a:pPr indent="0" marL="0">
-              <a:buNone/>
-            </a:pPr>
-            <a:r>
-              <a:rPr lang="en-US" sz="1200" b="1" spc="300" kern="0" dirty="0">
+            <a:pPr marL="0" indent="0">
+              <a:buNone/>
+            </a:pPr>
+            <a:r>
+              <a:rPr lang="en-US" sz="1200" b="1" kern="0" spc="300" dirty="0">
                 <a:solidFill>
                   <a:srgbClr val="1B6FC2"/>
                 </a:solidFill>
@@ -8407,7 +8134,7 @@
           <a:bodyPr wrap="square" lIns="0" tIns="0" rIns="0" bIns="0" rtlCol="0" anchor="ctr"/>
           <a:lstStyle/>
           <a:p>
-            <a:pPr indent="0" marL="0">
+            <a:pPr marL="0" indent="0">
               <a:buNone/>
             </a:pPr>
             <a:r>
@@ -8427,14 +8154,14 @@
       </p:sp>
       <p:pic>
         <p:nvPicPr>
-          <p:cNvPr id="4" name="Image 0" descr="C:\Users\shamo\OneDrive - United Nations\UN-DCO\10 — Innovation Sanbox\The Grassroots\docs\screenshots\05-insights.png">    </p:cNvPr>
+          <p:cNvPr id="4" name="Image 0" descr="C:\Users\shamo\OneDrive - United Nations\UN-DCO\10 — Innovation Sanbox\The Grassroots\docs\screenshots\05-insights.png"/>
           <p:cNvPicPr>
             <a:picLocks noChangeAspect="1"/>
           </p:cNvPicPr>
           <p:nvPr/>
         </p:nvPicPr>
         <p:blipFill>
-          <a:blip r:embed="rId1"/>
+          <a:blip r:embed="rId3"/>
           <a:stretch>
             <a:fillRect/>
           </a:stretch>
@@ -8497,11 +8224,11 @@
           <a:bodyPr wrap="square" lIns="0" tIns="0" rIns="0" bIns="0" rtlCol="0" anchor="ctr"/>
           <a:lstStyle/>
           <a:p>
-            <a:pPr algn="ctr" indent="0" marL="0">
-              <a:buNone/>
-            </a:pPr>
-            <a:r>
-              <a:rPr lang="en-US" sz="1000" b="1" spc="200" kern="0" dirty="0">
+            <a:pPr marL="0" indent="0" algn="ctr">
+              <a:buNone/>
+            </a:pPr>
+            <a:r>
+              <a:rPr lang="en-US" sz="1000" b="1" kern="0" spc="200" dirty="0">
                 <a:solidFill>
                   <a:srgbClr val="A8760F"/>
                 </a:solidFill>
@@ -8536,7 +8263,7 @@
           <a:bodyPr wrap="square" lIns="0" tIns="0" rIns="0" bIns="0" rtlCol="0" anchor="t"/>
           <a:lstStyle/>
           <a:p>
-            <a:pPr indent="0" marL="0">
+            <a:pPr marL="0" indent="0">
               <a:buNone/>
             </a:pPr>
             <a:r>
@@ -8551,9 +8278,6 @@
               <a:t>Which region is delivering? Which funder's portfolio is struggling? Which goal is falling behind?
 </a:t>
             </a:r>
-            <a:pPr indent="0" marL="0">
-              <a:buNone/>
-            </a:pPr>
             <a:r>
               <a:rPr lang="en-US" sz="1300" dirty="0">
                 <a:solidFill>
@@ -8564,21 +8288,7 @@
                 <a:cs typeface="Calibri" pitchFamily="34" charset="-120"/>
               </a:rPr>
               <a:t>Every one of those is a single click — a live chart drawn from the same numbers the field reported, not a slide assembled the night before.
-</a:t>
-            </a:r>
-            <a:pPr indent="0" marL="0">
-              <a:buNone/>
-            </a:pPr>
-            <a:r>
-              <a:rPr lang="en-US" sz="1300" dirty="0">
-                <a:solidFill>
-                  <a:srgbClr val="5B6B7E"/>
-                </a:solidFill>
-                <a:latin typeface="Calibri" pitchFamily="34" charset="0"/>
-                <a:ea typeface="Calibri" pitchFamily="34" charset="-122"/>
-                <a:cs typeface="Calibri" pitchFamily="34" charset="-120"/>
-              </a:rPr>
-              <a:t>When the minister, the board or the donor asks a follow-up, you answer it in the room.</a:t>
+When the minister, the board or the donor asks a follow-up, you answer it in the room.</a:t>
             </a:r>
             <a:endParaRPr lang="en-US" sz="1300" dirty="0"/>
           </a:p>
@@ -8888,4 +8598,325 @@
     </a:ext>
   </a:extLst>
 </a:theme>
+</file>
+
+<file path=ppt/theme/theme2.xml><?xml version="1.0" encoding="utf-8"?>
+<a:theme xmlns:a="http://schemas.openxmlformats.org/drawingml/2006/main" name="Office Theme">
+  <a:themeElements>
+    <a:clrScheme name="Office">
+      <a:dk1>
+        <a:sysClr val="windowText" lastClr="000000"/>
+      </a:dk1>
+      <a:lt1>
+        <a:sysClr val="window" lastClr="FFFFFF"/>
+      </a:lt1>
+      <a:dk2>
+        <a:srgbClr val="0E2841"/>
+      </a:dk2>
+      <a:lt2>
+        <a:srgbClr val="E8E8E8"/>
+      </a:lt2>
+      <a:accent1>
+        <a:srgbClr val="156082"/>
+      </a:accent1>
+      <a:accent2>
+        <a:srgbClr val="E97132"/>
+      </a:accent2>
+      <a:accent3>
+        <a:srgbClr val="196B24"/>
+      </a:accent3>
+      <a:accent4>
+        <a:srgbClr val="0F9ED5"/>
+      </a:accent4>
+      <a:accent5>
+        <a:srgbClr val="A02B93"/>
+      </a:accent5>
+      <a:accent6>
+        <a:srgbClr val="4EA72E"/>
+      </a:accent6>
+      <a:hlink>
+        <a:srgbClr val="467886"/>
+      </a:hlink>
+      <a:folHlink>
+        <a:srgbClr val="96607D"/>
+      </a:folHlink>
+    </a:clrScheme>
+    <a:fontScheme name="Office">
+      <a:majorFont>
+        <a:latin typeface="Aptos Display" panose="02110004020202020204"/>
+        <a:ea typeface=""/>
+        <a:cs typeface=""/>
+        <a:font script="Jpan" typeface="游ゴシック Light"/>
+        <a:font script="Hang" typeface="맑은 고딕"/>
+        <a:font script="Hans" typeface="等线 Light"/>
+        <a:font script="Hant" typeface="新細明體"/>
+        <a:font script="Arab" typeface="Times New Roman"/>
+        <a:font script="Hebr" typeface="Times New Roman"/>
+        <a:font script="Thai" typeface="Angsana New"/>
+        <a:font script="Ethi" typeface="Nyala"/>
+        <a:font script="Beng" typeface="Vrinda"/>
+        <a:font script="Gujr" typeface="Shruti"/>
+        <a:font script="Khmr" typeface="MoolBoran"/>
+        <a:font script="Knda" typeface="Tunga"/>
+        <a:font script="Guru" typeface="Raavi"/>
+        <a:font script="Cans" typeface="Euphemia"/>
+        <a:font script="Cher" typeface="Plantagenet Cherokee"/>
+        <a:font script="Yiii" typeface="Microsoft Yi Baiti"/>
+        <a:font script="Tibt" typeface="Microsoft Himalaya"/>
+        <a:font script="Thaa" typeface="MV Boli"/>
+        <a:font script="Deva" typeface="Mangal"/>
+        <a:font script="Telu" typeface="Gautami"/>
+        <a:font script="Taml" typeface="Latha"/>
+        <a:font script="Syrc" typeface="Estrangelo Edessa"/>
+        <a:font script="Orya" typeface="Kalinga"/>
+        <a:font script="Mlym" typeface="Kartika"/>
+        <a:font script="Laoo" typeface="DokChampa"/>
+        <a:font script="Sinh" typeface="Iskoola Pota"/>
+        <a:font script="Mong" typeface="Mongolian Baiti"/>
+        <a:font script="Viet" typeface="Times New Roman"/>
+        <a:font script="Uigh" typeface="Microsoft Uighur"/>
+        <a:font script="Geor" typeface="Sylfaen"/>
+        <a:font script="Armn" typeface="Arial"/>
+        <a:font script="Bugi" typeface="Leelawadee UI"/>
+        <a:font script="Bopo" typeface="Microsoft JhengHei"/>
+        <a:font script="Java" typeface="Javanese Text"/>
+        <a:font script="Lisu" typeface="Segoe UI"/>
+        <a:font script="Mymr" typeface="Myanmar Text"/>
+        <a:font script="Nkoo" typeface="Ebrima"/>
+        <a:font script="Olck" typeface="Nirmala UI"/>
+        <a:font script="Osma" typeface="Ebrima"/>
+        <a:font script="Phag" typeface="Phagspa"/>
+        <a:font script="Syrn" typeface="Estrangelo Edessa"/>
+        <a:font script="Syrj" typeface="Estrangelo Edessa"/>
+        <a:font script="Syre" typeface="Estrangelo Edessa"/>
+        <a:font script="Sora" typeface="Nirmala UI"/>
+        <a:font script="Tale" typeface="Microsoft Tai Le"/>
+        <a:font script="Talu" typeface="Microsoft New Tai Lue"/>
+        <a:font script="Tfng" typeface="Ebrima"/>
+      </a:majorFont>
+      <a:minorFont>
+        <a:latin typeface="Aptos" panose="02110004020202020204"/>
+        <a:ea typeface=""/>
+        <a:cs typeface=""/>
+        <a:font script="Jpan" typeface="游ゴシック"/>
+        <a:font script="Hang" typeface="맑은 고딕"/>
+        <a:font script="Hans" typeface="等线"/>
+        <a:font script="Hant" typeface="新細明體"/>
+        <a:font script="Arab" typeface="Arial"/>
+        <a:font script="Hebr" typeface="Arial"/>
+        <a:font script="Thai" typeface="Cordia New"/>
+        <a:font script="Ethi" typeface="Nyala"/>
+        <a:font script="Beng" typeface="Vrinda"/>
+        <a:font script="Gujr" typeface="Shruti"/>
+        <a:font script="Khmr" typeface="DaunPenh"/>
+        <a:font script="Knda" typeface="Tunga"/>
+        <a:font script="Guru" typeface="Raavi"/>
+        <a:font script="Cans" typeface="Euphemia"/>
+        <a:font script="Cher" typeface="Plantagenet Cherokee"/>
+        <a:font script="Yiii" typeface="Microsoft Yi Baiti"/>
+        <a:font script="Tibt" typeface="Microsoft Himalaya"/>
+        <a:font script="Thaa" typeface="MV Boli"/>
+        <a:font script="Deva" typeface="Mangal"/>
+        <a:font script="Telu" typeface="Gautami"/>
+        <a:font script="Taml" typeface="Latha"/>
+        <a:font script="Syrc" typeface="Estrangelo Edessa"/>
+        <a:font script="Orya" typeface="Kalinga"/>
+        <a:font script="Mlym" typeface="Kartika"/>
+        <a:font script="Laoo" typeface="DokChampa"/>
+        <a:font script="Sinh" typeface="Iskoola Pota"/>
+        <a:font script="Mong" typeface="Mongolian Baiti"/>
+        <a:font script="Viet" typeface="Arial"/>
+        <a:font script="Uigh" typeface="Microsoft Uighur"/>
+        <a:font script="Geor" typeface="Sylfaen"/>
+        <a:font script="Armn" typeface="Arial"/>
+        <a:font script="Bugi" typeface="Leelawadee UI"/>
+        <a:font script="Bopo" typeface="Microsoft JhengHei"/>
+        <a:font script="Java" typeface="Javanese Text"/>
+        <a:font script="Lisu" typeface="Segoe UI"/>
+        <a:font script="Mymr" typeface="Myanmar Text"/>
+        <a:font script="Nkoo" typeface="Ebrima"/>
+        <a:font script="Olck" typeface="Nirmala UI"/>
+        <a:font script="Osma" typeface="Ebrima"/>
+        <a:font script="Phag" typeface="Phagspa"/>
+        <a:font script="Syrn" typeface="Estrangelo Edessa"/>
+        <a:font script="Syrj" typeface="Estrangelo Edessa"/>
+        <a:font script="Syre" typeface="Estrangelo Edessa"/>
+        <a:font script="Sora" typeface="Nirmala UI"/>
+        <a:font script="Tale" typeface="Microsoft Tai Le"/>
+        <a:font script="Talu" typeface="Microsoft New Tai Lue"/>
+        <a:font script="Tfng" typeface="Ebrima"/>
+      </a:minorFont>
+    </a:fontScheme>
+    <a:fmtScheme name="Office">
+      <a:fillStyleLst>
+        <a:solidFill>
+          <a:schemeClr val="phClr"/>
+        </a:solidFill>
+        <a:gradFill rotWithShape="1">
+          <a:gsLst>
+            <a:gs pos="0">
+              <a:schemeClr val="phClr">
+                <a:lumMod val="110000"/>
+                <a:satMod val="105000"/>
+                <a:tint val="67000"/>
+              </a:schemeClr>
+            </a:gs>
+            <a:gs pos="50000">
+              <a:schemeClr val="phClr">
+                <a:lumMod val="105000"/>
+                <a:satMod val="103000"/>
+                <a:tint val="73000"/>
+              </a:schemeClr>
+            </a:gs>
+            <a:gs pos="100000">
+              <a:schemeClr val="phClr">
+                <a:lumMod val="105000"/>
+                <a:satMod val="109000"/>
+                <a:tint val="81000"/>
+              </a:schemeClr>
+            </a:gs>
+          </a:gsLst>
+          <a:lin ang="5400000" scaled="0"/>
+        </a:gradFill>
+        <a:gradFill rotWithShape="1">
+          <a:gsLst>
+            <a:gs pos="0">
+              <a:schemeClr val="phClr">
+                <a:satMod val="103000"/>
+                <a:lumMod val="102000"/>
+                <a:tint val="94000"/>
+              </a:schemeClr>
+            </a:gs>
+            <a:gs pos="50000">
+              <a:schemeClr val="phClr">
+                <a:satMod val="110000"/>
+                <a:lumMod val="100000"/>
+                <a:shade val="100000"/>
+              </a:schemeClr>
+            </a:gs>
+            <a:gs pos="100000">
+              <a:schemeClr val="phClr">
+                <a:lumMod val="99000"/>
+                <a:satMod val="120000"/>
+                <a:shade val="78000"/>
+              </a:schemeClr>
+            </a:gs>
+          </a:gsLst>
+          <a:lin ang="5400000" scaled="0"/>
+        </a:gradFill>
+      </a:fillStyleLst>
+      <a:lnStyleLst>
+        <a:ln w="12700" cap="flat" cmpd="sng" algn="ctr">
+          <a:solidFill>
+            <a:schemeClr val="phClr"/>
+          </a:solidFill>
+          <a:prstDash val="solid"/>
+          <a:miter lim="800000"/>
+        </a:ln>
+        <a:ln w="19050" cap="flat" cmpd="sng" algn="ctr">
+          <a:solidFill>
+            <a:schemeClr val="phClr"/>
+          </a:solidFill>
+          <a:prstDash val="solid"/>
+          <a:miter lim="800000"/>
+        </a:ln>
+        <a:ln w="25400" cap="flat" cmpd="sng" algn="ctr">
+          <a:solidFill>
+            <a:schemeClr val="phClr"/>
+          </a:solidFill>
+          <a:prstDash val="solid"/>
+          <a:miter lim="800000"/>
+        </a:ln>
+      </a:lnStyleLst>
+      <a:effectStyleLst>
+        <a:effectStyle>
+          <a:effectLst/>
+        </a:effectStyle>
+        <a:effectStyle>
+          <a:effectLst/>
+        </a:effectStyle>
+        <a:effectStyle>
+          <a:effectLst>
+            <a:outerShdw blurRad="57150" dist="19050" dir="5400000" algn="ctr" rotWithShape="0">
+              <a:srgbClr val="000000">
+                <a:alpha val="63000"/>
+              </a:srgbClr>
+            </a:outerShdw>
+          </a:effectLst>
+        </a:effectStyle>
+      </a:effectStyleLst>
+      <a:bgFillStyleLst>
+        <a:solidFill>
+          <a:schemeClr val="phClr"/>
+        </a:solidFill>
+        <a:solidFill>
+          <a:schemeClr val="phClr">
+            <a:tint val="95000"/>
+            <a:satMod val="170000"/>
+          </a:schemeClr>
+        </a:solidFill>
+        <a:gradFill rotWithShape="1">
+          <a:gsLst>
+            <a:gs pos="0">
+              <a:schemeClr val="phClr">
+                <a:tint val="93000"/>
+                <a:satMod val="150000"/>
+                <a:shade val="98000"/>
+                <a:lumMod val="102000"/>
+              </a:schemeClr>
+            </a:gs>
+            <a:gs pos="50000">
+              <a:schemeClr val="phClr">
+                <a:tint val="98000"/>
+                <a:satMod val="130000"/>
+                <a:shade val="90000"/>
+                <a:lumMod val="103000"/>
+              </a:schemeClr>
+            </a:gs>
+            <a:gs pos="100000">
+              <a:schemeClr val="phClr">
+                <a:shade val="63000"/>
+                <a:satMod val="120000"/>
+              </a:schemeClr>
+            </a:gs>
+          </a:gsLst>
+          <a:lin ang="5400000" scaled="0"/>
+        </a:gradFill>
+      </a:bgFillStyleLst>
+    </a:fmtScheme>
+  </a:themeElements>
+  <a:objectDefaults>
+    <a:lnDef>
+      <a:spPr/>
+      <a:bodyPr/>
+      <a:lstStyle/>
+      <a:style>
+        <a:lnRef idx="2">
+          <a:schemeClr val="accent1"/>
+        </a:lnRef>
+        <a:fillRef idx="0">
+          <a:schemeClr val="accent1"/>
+        </a:fillRef>
+        <a:effectRef idx="1">
+          <a:schemeClr val="accent1"/>
+        </a:effectRef>
+        <a:fontRef idx="minor">
+          <a:schemeClr val="tx1"/>
+        </a:fontRef>
+      </a:style>
+    </a:lnDef>
+  </a:objectDefaults>
+  <a:extraClrSchemeLst/>
+  <a:extLst>
+    <a:ext uri="{05A4C25C-085E-4340-85A3-A5531E510DB2}">
+      <thm15:themeFamily xmlns:thm15="http://schemas.microsoft.com/office/thememl/2012/main" name="Office Theme" id="{2E142A2C-CD16-42D6-873A-C26D2A0506FA}" vid="{1BDDFF52-6CD6-40A5-AB3C-68EB2F1E4D0A}"/>
+    </a:ext>
+  </a:extLst>
+</a:theme>
+</file>
+
+<file path=docMetadata/LabelInfo.xml><?xml version="1.0" encoding="utf-8"?>
+<clbl:labelList xmlns:clbl="http://schemas.microsoft.com/office/2020/mipLabelMetadata">
+  <clbl:label id="{8b77875e-5908-45a0-9cb4-dec9ae074618}" enabled="1" method="Privileged" siteId="{0f9e35db-544f-4f60-bdcc-5ea416e6dc70}" removed="0"/>
+</clbl:labelList>
 </file>
</xml_diff>

<commit_message>
Scope Lead forecast briefs per project; add Forecast and Communication slides to the deck
Co-Authored-By: Claude Fable 5 <noreply@anthropic.com>
</commit_message>
<xml_diff>
--- a/docs/The-Grassroots-Platform-Overview.pptx
+++ b/docs/The-Grassroots-Platform-Overview.pptx
@@ -13,10 +13,12 @@
     <p:sldId id="258" r:id="rId4"/>
     <p:sldId id="259" r:id="rId5"/>
     <p:sldId id="260" r:id="rId6"/>
+    <p:sldId id="268" r:id="rId19"/>
     <p:sldId id="261" r:id="rId7"/>
     <p:sldId id="262" r:id="rId8"/>
     <p:sldId id="263" r:id="rId9"/>
     <p:sldId id="264" r:id="rId10"/>
+    <p:sldId id="269" r:id="rId20"/>
     <p:sldId id="265" r:id="rId11"/>
     <p:sldId id="266" r:id="rId12"/>
     <p:sldId id="267" r:id="rId13"/>
@@ -3783,6 +3785,1336 @@
               <a:t>And remember as you explore: the portfolio inside is sample data, invented to show you the functions.</a:t>
             </a:r>
             <a:endParaRPr lang="en-US" sz="1300" dirty="0"/>
+          </a:p>
+        </p:txBody>
+      </p:sp>
+    </p:spTree>
+  </p:cSld>
+  <p:clrMapOvr>
+    <a:masterClrMapping/>
+  </p:clrMapOvr>
+  <p:transition spd="slow">
+    <p:push/>
+  </p:transition>
+</p:sld>
+</file>
+
+<file path=ppt/slides/slide13.xml><?xml version="1.0" encoding="utf-8"?>
+<p:sld xmlns:a="http://schemas.openxmlformats.org/drawingml/2006/main" xmlns:r="http://schemas.openxmlformats.org/officeDocument/2006/relationships" xmlns:p="http://schemas.openxmlformats.org/presentationml/2006/main">
+  <p:cSld name="Forecast">
+    <p:bg>
+      <p:bgPr>
+        <a:solidFill>
+          <a:srgbClr val="FFFFFF"/>
+        </a:solidFill>
+        <a:effectLst/>
+      </p:bgPr>
+    </p:bg>
+    <p:spTree>
+      <p:nvGrpSpPr>
+        <p:cNvPr id="1" name=""/>
+        <p:cNvGrpSpPr/>
+        <p:nvPr/>
+      </p:nvGrpSpPr>
+      <p:grpSpPr>
+        <a:xfrm>
+          <a:off x="0" y="0"/>
+          <a:ext cx="0" cy="0"/>
+          <a:chOff x="0" y="0"/>
+          <a:chExt cx="0" cy="0"/>
+        </a:xfrm>
+      </p:grpSpPr>
+      <p:sp>
+        <p:nvSpPr>
+          <p:cNvPr id="2" name="Text 0"/>
+          <p:cNvSpPr/>
+          <p:nvPr/>
+        </p:nvSpPr>
+        <p:spPr>
+          <a:xfrm>
+            <a:off x="685800" y="320040"/>
+            <a:ext cx="10789920" cy="274320"/>
+          </a:xfrm>
+          <a:prstGeom prst="rect">
+            <a:avLst/>
+          </a:prstGeom>
+          <a:noFill/>
+          <a:ln/>
+        </p:spPr>
+        <p:txBody>
+          <a:bodyPr wrap="square" lIns="0" tIns="0" rIns="0" bIns="0" rtlCol="0" anchor="ctr"/>
+          <a:lstStyle/>
+          <a:p>
+            <a:pPr marL="0" indent="0">
+              <a:buNone/>
+            </a:pPr>
+            <a:r>
+              <a:rPr lang="en-US" sz="1200" b="1" kern="0" spc="300" dirty="0">
+                <a:solidFill>
+                  <a:srgbClr val="1B6FC2"/>
+                </a:solidFill>
+                <a:latin typeface="Calibri" pitchFamily="34" charset="0"/>
+                <a:ea typeface="Calibri" pitchFamily="34" charset="-122"/>
+                <a:cs typeface="Calibri" pitchFamily="34" charset="-120"/>
+              </a:rPr>
+              <a:t>THE QUESTION EVERY FUNDER ASKS</a:t>
+            </a:r>
+            <a:endParaRPr lang="en-US" sz="1200" dirty="0"/>
+          </a:p>
+        </p:txBody>
+      </p:sp>
+      <p:sp>
+        <p:nvSpPr>
+          <p:cNvPr id="3" name="Text 1"/>
+          <p:cNvSpPr/>
+          <p:nvPr/>
+        </p:nvSpPr>
+        <p:spPr>
+          <a:xfrm>
+            <a:off x="685800" y="566928"/>
+            <a:ext cx="10789920" cy="914400"/>
+          </a:xfrm>
+          <a:prstGeom prst="rect">
+            <a:avLst/>
+          </a:prstGeom>
+          <a:noFill/>
+          <a:ln/>
+        </p:spPr>
+        <p:txBody>
+          <a:bodyPr wrap="square" lIns="0" tIns="0" rIns="0" bIns="0" rtlCol="0" anchor="ctr"/>
+          <a:lstStyle/>
+          <a:p>
+            <a:pPr marL="0" indent="0">
+              <a:buNone/>
+            </a:pPr>
+            <a:r>
+              <a:rPr lang="en-US" sz="3600" b="1" dirty="0">
+                <a:solidFill>
+                  <a:srgbClr val="152437"/>
+                </a:solidFill>
+                <a:latin typeface="Cambria" pitchFamily="34" charset="0"/>
+                <a:ea typeface="Cambria" pitchFamily="34" charset="-122"/>
+                <a:cs typeface="Cambria" pitchFamily="34" charset="-120"/>
+              </a:rPr>
+              <a:t>Where will we land when the plan ends?</a:t>
+            </a:r>
+            <a:endParaRPr lang="en-US" sz="3600" dirty="0"/>
+          </a:p>
+        </p:txBody>
+      </p:sp>
+      <p:sp>
+        <p:nvSpPr>
+          <p:cNvPr id="4" name="Text 2"/>
+          <p:cNvSpPr/>
+          <p:nvPr/>
+        </p:nvSpPr>
+        <p:spPr>
+          <a:xfrm>
+            <a:off x="685800" y="1691640"/>
+            <a:ext cx="10424160" cy="640080"/>
+          </a:xfrm>
+          <a:prstGeom prst="rect">
+            <a:avLst/>
+          </a:prstGeom>
+          <a:noFill/>
+          <a:ln/>
+        </p:spPr>
+        <p:txBody>
+          <a:bodyPr wrap="square" lIns="0" tIns="0" rIns="0" bIns="0" rtlCol="0" anchor="ctr"/>
+          <a:lstStyle/>
+          <a:p>
+            <a:pPr marL="0" indent="0">
+              <a:buNone/>
+            </a:pPr>
+            <a:r>
+              <a:rPr lang="en-US" sz="1550" dirty="0">
+                <a:solidFill>
+                  <a:srgbClr val="5B6B7E"/>
+                </a:solidFill>
+                <a:latin typeface="Calibri" pitchFamily="34" charset="0"/>
+                <a:ea typeface="Calibri" pitchFamily="34" charset="-122"/>
+                <a:cs typeface="Calibri" pitchFamily="34" charset="-120"/>
+              </a:rPr>
+              <a:t>Traffic lights say how things stand today. The Forecast goes further: it reads the pace of every indicator — how fast the numbers have actually moved, month by month — and projects it to the end of the plan. Not one guess: three honest scenarios, redrawn every time the field reports.</a:t>
+            </a:r>
+            <a:endParaRPr lang="en-US" sz="1550" dirty="0"/>
+          </a:p>
+        </p:txBody>
+      </p:sp>
+      <p:sp>
+        <p:nvSpPr>
+          <p:cNvPr id="5" name="Shape 3"/>
+          <p:cNvSpPr/>
+          <p:nvPr/>
+        </p:nvSpPr>
+        <p:spPr>
+          <a:xfrm>
+            <a:off x="685800" y="2606040"/>
+            <a:ext cx="3383280" cy="1920240"/>
+          </a:xfrm>
+          <a:prstGeom prst="roundRect">
+            <a:avLst>
+              <a:gd name="adj" fmla="val 4762"/>
+            </a:avLst>
+          </a:prstGeom>
+          <a:solidFill>
+            <a:srgbClr val="EAF3FC"/>
+          </a:solidFill>
+          <a:ln w="9525">
+            <a:solidFill>
+              <a:srgbClr val="CFE3F7"/>
+            </a:solidFill>
+            <a:prstDash val="solid"/>
+          </a:ln>
+        </p:spPr>
+      </p:sp>
+      <p:sp>
+        <p:nvSpPr>
+          <p:cNvPr id="6" name="Shape 4"/>
+          <p:cNvSpPr/>
+          <p:nvPr/>
+        </p:nvSpPr>
+        <p:spPr>
+          <a:xfrm>
+            <a:off x="978408" y="2880360"/>
+            <a:ext cx="502920" cy="502920"/>
+          </a:xfrm>
+          <a:prstGeom prst="ellipse">
+            <a:avLst/>
+          </a:prstGeom>
+          <a:solidFill>
+            <a:srgbClr val="16A34A"/>
+          </a:solidFill>
+          <a:ln w="12700">
+            <a:solidFill>
+              <a:srgbClr val="16A34A"/>
+            </a:solidFill>
+            <a:prstDash val="solid"/>
+          </a:ln>
+        </p:spPr>
+      </p:sp>
+      <p:sp>
+        <p:nvSpPr>
+          <p:cNvPr id="7" name="Text 5"/>
+          <p:cNvSpPr/>
+          <p:nvPr/>
+        </p:nvSpPr>
+        <p:spPr>
+          <a:xfrm>
+            <a:off x="978408" y="3520440"/>
+            <a:ext cx="2788920" cy="365760"/>
+          </a:xfrm>
+          <a:prstGeom prst="rect">
+            <a:avLst/>
+          </a:prstGeom>
+          <a:noFill/>
+          <a:ln/>
+        </p:spPr>
+        <p:txBody>
+          <a:bodyPr wrap="square" lIns="0" tIns="0" rIns="0" bIns="0" rtlCol="0" anchor="ctr"/>
+          <a:lstStyle/>
+          <a:p>
+            <a:pPr marL="0" indent="0">
+              <a:buNone/>
+            </a:pPr>
+            <a:r>
+              <a:rPr lang="en-US" sz="1900" b="1" dirty="0">
+                <a:solidFill>
+                  <a:srgbClr val="152437"/>
+                </a:solidFill>
+                <a:latin typeface="Cambria" pitchFamily="34" charset="0"/>
+                <a:ea typeface="Cambria" pitchFamily="34" charset="-122"/>
+                <a:cs typeface="Cambria" pitchFamily="34" charset="-120"/>
+              </a:rPr>
+              <a:t>Best case</a:t>
+            </a:r>
+            <a:endParaRPr lang="en-US" sz="1900" dirty="0"/>
+          </a:p>
+        </p:txBody>
+      </p:sp>
+      <p:sp>
+        <p:nvSpPr>
+          <p:cNvPr id="8" name="Text 6"/>
+          <p:cNvSpPr/>
+          <p:nvPr/>
+        </p:nvSpPr>
+        <p:spPr>
+          <a:xfrm>
+            <a:off x="978408" y="3913632"/>
+            <a:ext cx="2788920" cy="548640"/>
+          </a:xfrm>
+          <a:prstGeom prst="rect">
+            <a:avLst/>
+          </a:prstGeom>
+          <a:noFill/>
+          <a:ln/>
+        </p:spPr>
+        <p:txBody>
+          <a:bodyPr wrap="square" lIns="0" tIns="0" rIns="0" bIns="0" rtlCol="0" anchor="t"/>
+          <a:lstStyle/>
+          <a:p>
+            <a:pPr marL="0" indent="0">
+              <a:buNone/>
+            </a:pPr>
+            <a:r>
+              <a:rPr lang="en-US" sz="1200" dirty="0">
+                <a:solidFill>
+                  <a:srgbClr val="5B6B7E"/>
+                </a:solidFill>
+                <a:latin typeface="Calibri" pitchFamily="34" charset="0"/>
+                <a:ea typeface="Calibri" pitchFamily="34" charset="-122"/>
+                <a:cs typeface="Calibri" pitchFamily="34" charset="-120"/>
+              </a:rPr>
+              <a:t>Where the numbers land if delivery holds its strongest recent pace to the end.</a:t>
+            </a:r>
+            <a:endParaRPr lang="en-US" sz="1200" dirty="0"/>
+          </a:p>
+        </p:txBody>
+      </p:sp>
+      <p:sp>
+        <p:nvSpPr>
+          <p:cNvPr id="9" name="Shape 7"/>
+          <p:cNvSpPr/>
+          <p:nvPr/>
+        </p:nvSpPr>
+        <p:spPr>
+          <a:xfrm>
+            <a:off x="4398264" y="2606040"/>
+            <a:ext cx="3383280" cy="1920240"/>
+          </a:xfrm>
+          <a:prstGeom prst="roundRect">
+            <a:avLst>
+              <a:gd name="adj" fmla="val 4762"/>
+            </a:avLst>
+          </a:prstGeom>
+          <a:solidFill>
+            <a:srgbClr val="EAF3FC"/>
+          </a:solidFill>
+          <a:ln w="9525">
+            <a:solidFill>
+              <a:srgbClr val="CFE3F7"/>
+            </a:solidFill>
+            <a:prstDash val="solid"/>
+          </a:ln>
+        </p:spPr>
+      </p:sp>
+      <p:sp>
+        <p:nvSpPr>
+          <p:cNvPr id="10" name="Shape 8"/>
+          <p:cNvSpPr/>
+          <p:nvPr/>
+        </p:nvSpPr>
+        <p:spPr>
+          <a:xfrm>
+            <a:off x="4690872" y="2880360"/>
+            <a:ext cx="502920" cy="502920"/>
+          </a:xfrm>
+          <a:prstGeom prst="ellipse">
+            <a:avLst/>
+          </a:prstGeom>
+          <a:solidFill>
+            <a:srgbClr val="2563EB"/>
+          </a:solidFill>
+          <a:ln w="12700">
+            <a:solidFill>
+              <a:srgbClr val="2563EB"/>
+            </a:solidFill>
+            <a:prstDash val="solid"/>
+          </a:ln>
+        </p:spPr>
+      </p:sp>
+      <p:sp>
+        <p:nvSpPr>
+          <p:cNvPr id="11" name="Text 9"/>
+          <p:cNvSpPr/>
+          <p:nvPr/>
+        </p:nvSpPr>
+        <p:spPr>
+          <a:xfrm>
+            <a:off x="4690872" y="3520440"/>
+            <a:ext cx="2788920" cy="365760"/>
+          </a:xfrm>
+          <a:prstGeom prst="rect">
+            <a:avLst/>
+          </a:prstGeom>
+          <a:noFill/>
+          <a:ln/>
+        </p:spPr>
+        <p:txBody>
+          <a:bodyPr wrap="square" lIns="0" tIns="0" rIns="0" bIns="0" rtlCol="0" anchor="ctr"/>
+          <a:lstStyle/>
+          <a:p>
+            <a:pPr marL="0" indent="0">
+              <a:buNone/>
+            </a:pPr>
+            <a:r>
+              <a:rPr lang="en-US" sz="1900" b="1" dirty="0">
+                <a:solidFill>
+                  <a:srgbClr val="152437"/>
+                </a:solidFill>
+                <a:latin typeface="Cambria" pitchFamily="34" charset="0"/>
+                <a:ea typeface="Cambria" pitchFamily="34" charset="-122"/>
+                <a:cs typeface="Cambria" pitchFamily="34" charset="-120"/>
+              </a:rPr>
+              <a:t>Realistic</a:t>
+            </a:r>
+            <a:endParaRPr lang="en-US" sz="1900" dirty="0"/>
+          </a:p>
+        </p:txBody>
+      </p:sp>
+      <p:sp>
+        <p:nvSpPr>
+          <p:cNvPr id="12" name="Text 10"/>
+          <p:cNvSpPr/>
+          <p:nvPr/>
+        </p:nvSpPr>
+        <p:spPr>
+          <a:xfrm>
+            <a:off x="4690872" y="3913632"/>
+            <a:ext cx="2788920" cy="548640"/>
+          </a:xfrm>
+          <a:prstGeom prst="rect">
+            <a:avLst/>
+          </a:prstGeom>
+          <a:noFill/>
+          <a:ln/>
+        </p:spPr>
+        <p:txBody>
+          <a:bodyPr wrap="square" lIns="0" tIns="0" rIns="0" bIns="0" rtlCol="0" anchor="t"/>
+          <a:lstStyle/>
+          <a:p>
+            <a:pPr marL="0" indent="0">
+              <a:buNone/>
+            </a:pPr>
+            <a:r>
+              <a:rPr lang="en-US" sz="1200" dirty="0">
+                <a:solidFill>
+                  <a:srgbClr val="5B6B7E"/>
+                </a:solidFill>
+                <a:latin typeface="Calibri" pitchFamily="34" charset="0"/>
+                <a:ea typeface="Calibri" pitchFamily="34" charset="-122"/>
+                <a:cs typeface="Calibri" pitchFamily="34" charset="-120"/>
+              </a:rPr>
+              <a:t>Where today's pace actually lands — the number to plan around.</a:t>
+            </a:r>
+            <a:endParaRPr lang="en-US" sz="1200" dirty="0"/>
+          </a:p>
+        </p:txBody>
+      </p:sp>
+      <p:sp>
+        <p:nvSpPr>
+          <p:cNvPr id="13" name="Shape 11"/>
+          <p:cNvSpPr/>
+          <p:nvPr/>
+        </p:nvSpPr>
+        <p:spPr>
+          <a:xfrm>
+            <a:off x="8110728" y="2606040"/>
+            <a:ext cx="3383280" cy="1920240"/>
+          </a:xfrm>
+          <a:prstGeom prst="roundRect">
+            <a:avLst>
+              <a:gd name="adj" fmla="val 4762"/>
+            </a:avLst>
+          </a:prstGeom>
+          <a:solidFill>
+            <a:srgbClr val="EAF3FC"/>
+          </a:solidFill>
+          <a:ln w="9525">
+            <a:solidFill>
+              <a:srgbClr val="CFE3F7"/>
+            </a:solidFill>
+            <a:prstDash val="solid"/>
+          </a:ln>
+        </p:spPr>
+      </p:sp>
+      <p:sp>
+        <p:nvSpPr>
+          <p:cNvPr id="14" name="Shape 12"/>
+          <p:cNvSpPr/>
+          <p:nvPr/>
+        </p:nvSpPr>
+        <p:spPr>
+          <a:xfrm>
+            <a:off x="8403336" y="2880360"/>
+            <a:ext cx="502920" cy="502920"/>
+          </a:xfrm>
+          <a:prstGeom prst="ellipse">
+            <a:avLst/>
+          </a:prstGeom>
+          <a:solidFill>
+            <a:srgbClr val="F59E0B"/>
+          </a:solidFill>
+          <a:ln w="12700">
+            <a:solidFill>
+              <a:srgbClr val="F59E0B"/>
+            </a:solidFill>
+            <a:prstDash val="solid"/>
+          </a:ln>
+        </p:spPr>
+      </p:sp>
+      <p:sp>
+        <p:nvSpPr>
+          <p:cNvPr id="15" name="Text 13"/>
+          <p:cNvSpPr/>
+          <p:nvPr/>
+        </p:nvSpPr>
+        <p:spPr>
+          <a:xfrm>
+            <a:off x="8403336" y="3520440"/>
+            <a:ext cx="2788920" cy="365760"/>
+          </a:xfrm>
+          <a:prstGeom prst="rect">
+            <a:avLst/>
+          </a:prstGeom>
+          <a:noFill/>
+          <a:ln/>
+        </p:spPr>
+        <p:txBody>
+          <a:bodyPr wrap="square" lIns="0" tIns="0" rIns="0" bIns="0" rtlCol="0" anchor="ctr"/>
+          <a:lstStyle/>
+          <a:p>
+            <a:pPr marL="0" indent="0">
+              <a:buNone/>
+            </a:pPr>
+            <a:r>
+              <a:rPr lang="en-US" sz="1900" b="1" dirty="0">
+                <a:solidFill>
+                  <a:srgbClr val="152437"/>
+                </a:solidFill>
+                <a:latin typeface="Cambria" pitchFamily="34" charset="0"/>
+                <a:ea typeface="Cambria" pitchFamily="34" charset="-122"/>
+                <a:cs typeface="Cambria" pitchFamily="34" charset="-120"/>
+              </a:rPr>
+              <a:t>Worst case</a:t>
+            </a:r>
+            <a:endParaRPr lang="en-US" sz="1900" dirty="0"/>
+          </a:p>
+        </p:txBody>
+      </p:sp>
+      <p:sp>
+        <p:nvSpPr>
+          <p:cNvPr id="16" name="Text 14"/>
+          <p:cNvSpPr/>
+          <p:nvPr/>
+        </p:nvSpPr>
+        <p:spPr>
+          <a:xfrm>
+            <a:off x="8403336" y="3913632"/>
+            <a:ext cx="2788920" cy="548640"/>
+          </a:xfrm>
+          <a:prstGeom prst="rect">
+            <a:avLst/>
+          </a:prstGeom>
+          <a:noFill/>
+          <a:ln/>
+        </p:spPr>
+        <p:txBody>
+          <a:bodyPr wrap="square" lIns="0" tIns="0" rIns="0" bIns="0" rtlCol="0" anchor="t"/>
+          <a:lstStyle/>
+          <a:p>
+            <a:pPr marL="0" indent="0">
+              <a:buNone/>
+            </a:pPr>
+            <a:r>
+              <a:rPr lang="en-US" sz="1200" dirty="0">
+                <a:solidFill>
+                  <a:srgbClr val="5B6B7E"/>
+                </a:solidFill>
+                <a:latin typeface="Calibri" pitchFamily="34" charset="0"/>
+                <a:ea typeface="Calibri" pitchFamily="34" charset="-122"/>
+                <a:cs typeface="Calibri" pitchFamily="34" charset="-120"/>
+              </a:rPr>
+              <a:t>If the pace slips — a warning delivered early, not a surprise delivered late.</a:t>
+            </a:r>
+            <a:endParaRPr lang="en-US" sz="1200" dirty="0"/>
+          </a:p>
+        </p:txBody>
+      </p:sp>
+      <p:sp>
+        <p:nvSpPr>
+          <p:cNvPr id="17" name="Shape 15"/>
+          <p:cNvSpPr/>
+          <p:nvPr/>
+        </p:nvSpPr>
+        <p:spPr>
+          <a:xfrm>
+            <a:off x="685800" y="4892040"/>
+            <a:ext cx="10817352" cy="1234440"/>
+          </a:xfrm>
+          <a:prstGeom prst="roundRect">
+            <a:avLst>
+              <a:gd name="adj" fmla="val 7407"/>
+            </a:avLst>
+          </a:prstGeom>
+          <a:solidFill>
+            <a:srgbClr val="0E2A47"/>
+          </a:solidFill>
+          <a:ln w="12700">
+            <a:solidFill>
+              <a:srgbClr val="0E2A47"/>
+            </a:solidFill>
+            <a:prstDash val="solid"/>
+          </a:ln>
+        </p:spPr>
+      </p:sp>
+      <p:pic>
+        <p:nvPicPr>
+          <p:cNvPr id="18" name="Image 0" descr="bolt icon"/>
+          <p:cNvPicPr>
+            <a:picLocks noChangeAspect="1"/>
+          </p:cNvPicPr>
+          <p:nvPr/>
+        </p:nvPicPr>
+        <p:blipFill>
+          <a:blip r:embed="rId3"/>
+          <a:stretch>
+            <a:fillRect/>
+          </a:stretch>
+        </p:blipFill>
+        <p:spPr>
+          <a:xfrm>
+            <a:off x="960120" y="5257800"/>
+            <a:ext cx="457200" cy="457200"/>
+          </a:xfrm>
+          <a:prstGeom prst="rect">
+            <a:avLst/>
+          </a:prstGeom>
+        </p:spPr>
+      </p:pic>
+      <p:sp>
+        <p:nvSpPr>
+          <p:cNvPr id="19" name="Text 16"/>
+          <p:cNvSpPr/>
+          <p:nvPr/>
+        </p:nvSpPr>
+        <p:spPr>
+          <a:xfrm>
+            <a:off x="1600200" y="5029200"/>
+            <a:ext cx="9692640" cy="960120"/>
+          </a:xfrm>
+          <a:prstGeom prst="rect">
+            <a:avLst/>
+          </a:prstGeom>
+          <a:noFill/>
+          <a:ln/>
+        </p:spPr>
+        <p:txBody>
+          <a:bodyPr wrap="square" lIns="0" tIns="0" rIns="0" bIns="0" rtlCol="0" anchor="ctr"/>
+          <a:lstStyle/>
+          <a:p>
+            <a:pPr marL="0" indent="0">
+              <a:buNone/>
+            </a:pPr>
+            <a:r>
+              <a:rPr lang="en-US" sz="1350" b="1" dirty="0">
+                <a:solidFill>
+                  <a:srgbClr val="FFFFFF"/>
+                </a:solidFill>
+                <a:latin typeface="Calibri" pitchFamily="34" charset="0"/>
+                <a:ea typeface="Calibri" pitchFamily="34" charset="-122"/>
+                <a:cs typeface="Calibri" pitchFamily="34" charset="-120"/>
+              </a:rPr>
+              <a:t>Risk leads the page.  </a:t>
+            </a:r>
+            <a:r>
+              <a:rPr lang="en-US" sz="1350" dirty="0">
+                <a:solidFill>
+                  <a:srgbClr val="C9DDF2"/>
+                </a:solidFill>
+                <a:latin typeface="Calibri" pitchFamily="34" charset="0"/>
+                <a:ea typeface="Calibri" pitchFamily="34" charset="-122"/>
+                <a:cs typeface="Calibri" pitchFamily="34" charset="-120"/>
+              </a:rPr>
+              <a:t>The target most likely to be missed sits at the top — with months still on the clock and budget still in hand. And the Forecast is honest about itself: where reporting history is thin, it says its confidence is low rather than pretending to certainty.</a:t>
+            </a:r>
+            <a:endParaRPr lang="en-US" sz="1350" dirty="0"/>
+          </a:p>
+        </p:txBody>
+      </p:sp>
+    </p:spTree>
+  </p:cSld>
+  <p:clrMapOvr>
+    <a:masterClrMapping/>
+  </p:clrMapOvr>
+  <p:transition spd="slow">
+    <p:fade/>
+  </p:transition>
+</p:sld>
+</file>
+
+<file path=ppt/slides/slide14.xml><?xml version="1.0" encoding="utf-8"?>
+<p:sld xmlns:a="http://schemas.openxmlformats.org/drawingml/2006/main" xmlns:r="http://schemas.openxmlformats.org/officeDocument/2006/relationships" xmlns:p="http://schemas.openxmlformats.org/presentationml/2006/main">
+  <p:cSld name="Communication">
+    <p:bg>
+      <p:bgPr>
+        <a:solidFill>
+          <a:srgbClr val="0E2A47"/>
+        </a:solidFill>
+        <a:effectLst/>
+      </p:bgPr>
+    </p:bg>
+    <p:spTree>
+      <p:nvGrpSpPr>
+        <p:cNvPr id="1" name=""/>
+        <p:cNvGrpSpPr/>
+        <p:nvPr/>
+      </p:nvGrpSpPr>
+      <p:grpSpPr>
+        <a:xfrm>
+          <a:off x="0" y="0"/>
+          <a:ext cx="0" cy="0"/>
+          <a:chOff x="0" y="0"/>
+          <a:chExt cx="0" cy="0"/>
+        </a:xfrm>
+      </p:grpSpPr>
+      <p:sp>
+        <p:nvSpPr>
+          <p:cNvPr id="2" name="Shape 0"/>
+          <p:cNvSpPr/>
+          <p:nvPr/>
+        </p:nvSpPr>
+        <p:spPr>
+          <a:xfrm>
+            <a:off x="9875520" y="-1280160"/>
+            <a:ext cx="4572000" cy="4572000"/>
+          </a:xfrm>
+          <a:prstGeom prst="ellipse">
+            <a:avLst/>
+          </a:prstGeom>
+          <a:solidFill>
+            <a:srgbClr val="1B6FC2">
+              <a:alpha val="15000"/>
+            </a:srgbClr>
+          </a:solidFill>
+          <a:ln w="12700">
+            <a:solidFill>
+              <a:srgbClr val="1B6FC2"/>
+            </a:solidFill>
+            <a:prstDash val="solid"/>
+          </a:ln>
+        </p:spPr>
+      </p:sp>
+      <p:sp>
+        <p:nvSpPr>
+          <p:cNvPr id="3" name="Shape 1"/>
+          <p:cNvSpPr/>
+          <p:nvPr/>
+        </p:nvSpPr>
+        <p:spPr>
+          <a:xfrm>
+            <a:off x="-1371600" y="4572000"/>
+            <a:ext cx="4114800" cy="4114800"/>
+          </a:xfrm>
+          <a:prstGeom prst="ellipse">
+            <a:avLst/>
+          </a:prstGeom>
+          <a:solidFill>
+            <a:srgbClr val="3E8BD9">
+              <a:alpha val="12000"/>
+            </a:srgbClr>
+          </a:solidFill>
+          <a:ln w="12700">
+            <a:solidFill>
+              <a:srgbClr val="3E8BD9"/>
+            </a:solidFill>
+            <a:prstDash val="solid"/>
+          </a:ln>
+        </p:spPr>
+      </p:sp>
+      <p:sp>
+        <p:nvSpPr>
+          <p:cNvPr id="4" name="Text 2"/>
+          <p:cNvSpPr/>
+          <p:nvPr/>
+        </p:nvSpPr>
+        <p:spPr>
+          <a:xfrm>
+            <a:off x="685800" y="320040"/>
+            <a:ext cx="10789920" cy="274320"/>
+          </a:xfrm>
+          <a:prstGeom prst="rect">
+            <a:avLst/>
+          </a:prstGeom>
+          <a:noFill/>
+          <a:ln/>
+        </p:spPr>
+        <p:txBody>
+          <a:bodyPr wrap="square" lIns="0" tIns="0" rIns="0" bIns="0" rtlCol="0" anchor="ctr"/>
+          <a:lstStyle/>
+          <a:p>
+            <a:pPr marL="0" indent="0">
+              <a:buNone/>
+            </a:pPr>
+            <a:r>
+              <a:rPr lang="en-US" sz="1200" b="1" kern="0" spc="300" dirty="0">
+                <a:solidFill>
+                  <a:srgbClr val="F5B942"/>
+                </a:solidFill>
+                <a:latin typeface="Calibri" pitchFamily="34" charset="0"/>
+                <a:ea typeface="Calibri" pitchFamily="34" charset="-122"/>
+                <a:cs typeface="Calibri" pitchFamily="34" charset="-120"/>
+              </a:rPr>
+              <a:t>AND THE REPORTS DELIVER THEMSELVES</a:t>
+            </a:r>
+            <a:endParaRPr lang="en-US" sz="1200" dirty="0"/>
+          </a:p>
+        </p:txBody>
+      </p:sp>
+      <p:sp>
+        <p:nvSpPr>
+          <p:cNvPr id="5" name="Text 3"/>
+          <p:cNvSpPr/>
+          <p:nvPr/>
+        </p:nvSpPr>
+        <p:spPr>
+          <a:xfrm>
+            <a:off x="685800" y="1005840"/>
+            <a:ext cx="10789920" cy="1554480"/>
+          </a:xfrm>
+          <a:prstGeom prst="rect">
+            <a:avLst/>
+          </a:prstGeom>
+          <a:noFill/>
+          <a:ln/>
+        </p:spPr>
+        <p:txBody>
+          <a:bodyPr wrap="square" lIns="0" tIns="0" rIns="0" bIns="0" rtlCol="0" anchor="ctr"/>
+          <a:lstStyle/>
+          <a:p>
+            <a:pPr marL="0" indent="0">
+              <a:buNone/>
+            </a:pPr>
+            <a:r>
+              <a:rPr lang="en-US" sz="3800" b="1" dirty="0">
+                <a:solidFill>
+                  <a:srgbClr val="FFFFFF"/>
+                </a:solidFill>
+                <a:latin typeface="Cambria" pitchFamily="34" charset="0"/>
+                <a:ea typeface="Cambria" pitchFamily="34" charset="-122"/>
+                <a:cs typeface="Cambria" pitchFamily="34" charset="-120"/>
+              </a:rPr>
+              <a:t>Every lead receives their report —</a:t>
+            </a:r>
+            <a:endParaRPr lang="en-US" sz="3800" dirty="0"/>
+          </a:p>
+          <a:p>
+            <a:pPr marL="0" indent="0">
+              <a:buNone/>
+            </a:pPr>
+            <a:r>
+              <a:rPr lang="en-US" sz="3800" b="1" dirty="0">
+                <a:solidFill>
+                  <a:srgbClr val="FFFFFF"/>
+                </a:solidFill>
+                <a:latin typeface="Cambria" pitchFamily="34" charset="0"/>
+                <a:ea typeface="Cambria" pitchFamily="34" charset="-122"/>
+                <a:cs typeface="Cambria" pitchFamily="34" charset="-120"/>
+              </a:rPr>
+              <a:t>written, attached and sent.</a:t>
+            </a:r>
+            <a:endParaRPr lang="en-US" sz="3800" dirty="0"/>
+          </a:p>
+        </p:txBody>
+      </p:sp>
+      <p:sp>
+        <p:nvSpPr>
+          <p:cNvPr id="6" name="Shape 4"/>
+          <p:cNvSpPr/>
+          <p:nvPr/>
+        </p:nvSpPr>
+        <p:spPr>
+          <a:xfrm>
+            <a:off x="685800" y="2880360"/>
+            <a:ext cx="3383280" cy="2468880"/>
+          </a:xfrm>
+          <a:prstGeom prst="roundRect">
+            <a:avLst>
+              <a:gd name="adj" fmla="val 3704"/>
+            </a:avLst>
+          </a:prstGeom>
+          <a:solidFill>
+            <a:srgbClr val="16395F"/>
+          </a:solidFill>
+          <a:ln w="12700">
+            <a:solidFill>
+              <a:srgbClr val="16395F"/>
+            </a:solidFill>
+            <a:prstDash val="solid"/>
+          </a:ln>
+        </p:spPr>
+      </p:sp>
+      <p:sp>
+        <p:nvSpPr>
+          <p:cNvPr id="7" name="Shape 5"/>
+          <p:cNvSpPr/>
+          <p:nvPr/>
+        </p:nvSpPr>
+        <p:spPr>
+          <a:xfrm>
+            <a:off x="978408" y="3154680"/>
+            <a:ext cx="640080" cy="640080"/>
+          </a:xfrm>
+          <a:prstGeom prst="ellipse">
+            <a:avLst/>
+          </a:prstGeom>
+          <a:solidFill>
+            <a:srgbClr val="1B6FC2"/>
+          </a:solidFill>
+          <a:ln w="12700">
+            <a:solidFill>
+              <a:srgbClr val="1B6FC2"/>
+            </a:solidFill>
+            <a:prstDash val="solid"/>
+          </a:ln>
+        </p:spPr>
+      </p:sp>
+      <p:pic>
+        <p:nvPicPr>
+          <p:cNvPr id="8" name="Image 0" descr="check icon"/>
+          <p:cNvPicPr>
+            <a:picLocks noChangeAspect="1"/>
+          </p:cNvPicPr>
+          <p:nvPr/>
+        </p:nvPicPr>
+        <p:blipFill>
+          <a:blip r:embed="rId3"/>
+          <a:stretch>
+            <a:fillRect/>
+          </a:stretch>
+        </p:blipFill>
+        <p:spPr>
+          <a:xfrm>
+            <a:off x="1144829" y="3321101"/>
+            <a:ext cx="307238" cy="307238"/>
+          </a:xfrm>
+          <a:prstGeom prst="rect">
+            <a:avLst/>
+          </a:prstGeom>
+        </p:spPr>
+      </p:pic>
+      <p:sp>
+        <p:nvSpPr>
+          <p:cNvPr id="9" name="Text 6"/>
+          <p:cNvSpPr/>
+          <p:nvPr/>
+        </p:nvSpPr>
+        <p:spPr>
+          <a:xfrm>
+            <a:off x="978408" y="3931920"/>
+            <a:ext cx="2788920" cy="365760"/>
+          </a:xfrm>
+          <a:prstGeom prst="rect">
+            <a:avLst/>
+          </a:prstGeom>
+          <a:noFill/>
+          <a:ln/>
+        </p:spPr>
+        <p:txBody>
+          <a:bodyPr wrap="square" lIns="0" tIns="0" rIns="0" bIns="0" rtlCol="0" anchor="ctr"/>
+          <a:lstStyle/>
+          <a:p>
+            <a:pPr marL="0" indent="0">
+              <a:buNone/>
+            </a:pPr>
+            <a:r>
+              <a:rPr lang="en-US" sz="1700" b="1" dirty="0">
+                <a:solidFill>
+                  <a:srgbClr val="FFFFFF"/>
+                </a:solidFill>
+                <a:latin typeface="Cambria" pitchFamily="34" charset="0"/>
+                <a:ea typeface="Cambria" pitchFamily="34" charset="-122"/>
+                <a:cs typeface="Cambria" pitchFamily="34" charset="-120"/>
+              </a:rPr>
+              <a:t>Written by the platform</a:t>
+            </a:r>
+            <a:endParaRPr lang="en-US" sz="1700" dirty="0"/>
+          </a:p>
+        </p:txBody>
+      </p:sp>
+      <p:sp>
+        <p:nvSpPr>
+          <p:cNvPr id="10" name="Text 7"/>
+          <p:cNvSpPr/>
+          <p:nvPr/>
+        </p:nvSpPr>
+        <p:spPr>
+          <a:xfrm>
+            <a:off x="978408" y="4315968"/>
+            <a:ext cx="2788920" cy="914400"/>
+          </a:xfrm>
+          <a:prstGeom prst="rect">
+            <a:avLst/>
+          </a:prstGeom>
+          <a:noFill/>
+          <a:ln/>
+        </p:spPr>
+        <p:txBody>
+          <a:bodyPr wrap="square" lIns="0" tIns="0" rIns="0" bIns="0" rtlCol="0" anchor="t"/>
+          <a:lstStyle/>
+          <a:p>
+            <a:pPr marL="0" indent="0">
+              <a:buNone/>
+            </a:pPr>
+            <a:r>
+              <a:rPr lang="en-US" sz="1250" dirty="0">
+                <a:solidFill>
+                  <a:srgbClr val="C9DDF2"/>
+                </a:solidFill>
+                <a:latin typeface="Calibri" pitchFamily="34" charset="0"/>
+                <a:ea typeface="Calibri" pitchFamily="34" charset="-122"/>
+                <a:cs typeface="Calibri" pitchFamily="34" charset="-120"/>
+              </a:rPr>
+              <a:t>Each month, a results report for every plan, project, funder, region and country — drawn from the same live numbers as the map.</a:t>
+            </a:r>
+            <a:endParaRPr lang="en-US" sz="1250" dirty="0"/>
+          </a:p>
+        </p:txBody>
+      </p:sp>
+      <p:sp>
+        <p:nvSpPr>
+          <p:cNvPr id="11" name="Shape 8"/>
+          <p:cNvSpPr/>
+          <p:nvPr/>
+        </p:nvSpPr>
+        <p:spPr>
+          <a:xfrm>
+            <a:off x="4398264" y="2880360"/>
+            <a:ext cx="3383280" cy="2468880"/>
+          </a:xfrm>
+          <a:prstGeom prst="roundRect">
+            <a:avLst>
+              <a:gd name="adj" fmla="val 3704"/>
+            </a:avLst>
+          </a:prstGeom>
+          <a:solidFill>
+            <a:srgbClr val="16395F"/>
+          </a:solidFill>
+          <a:ln w="12700">
+            <a:solidFill>
+              <a:srgbClr val="16395F"/>
+            </a:solidFill>
+            <a:prstDash val="solid"/>
+          </a:ln>
+        </p:spPr>
+      </p:sp>
+      <p:sp>
+        <p:nvSpPr>
+          <p:cNvPr id="12" name="Shape 9"/>
+          <p:cNvSpPr/>
+          <p:nvPr/>
+        </p:nvSpPr>
+        <p:spPr>
+          <a:xfrm>
+            <a:off x="4690872" y="3154680"/>
+            <a:ext cx="640080" cy="640080"/>
+          </a:xfrm>
+          <a:prstGeom prst="ellipse">
+            <a:avLst/>
+          </a:prstGeom>
+          <a:solidFill>
+            <a:srgbClr val="1B6FC2"/>
+          </a:solidFill>
+          <a:ln w="12700">
+            <a:solidFill>
+              <a:srgbClr val="1B6FC2"/>
+            </a:solidFill>
+            <a:prstDash val="solid"/>
+          </a:ln>
+        </p:spPr>
+      </p:sp>
+      <p:pic>
+        <p:nvPicPr>
+          <p:cNvPr id="13" name="Image 1" descr="bolt icon"/>
+          <p:cNvPicPr>
+            <a:picLocks noChangeAspect="1"/>
+          </p:cNvPicPr>
+          <p:nvPr/>
+        </p:nvPicPr>
+        <p:blipFill>
+          <a:blip r:embed="rId4"/>
+          <a:stretch>
+            <a:fillRect/>
+          </a:stretch>
+        </p:blipFill>
+        <p:spPr>
+          <a:xfrm>
+            <a:off x="4857293" y="3321101"/>
+            <a:ext cx="307238" cy="307238"/>
+          </a:xfrm>
+          <a:prstGeom prst="rect">
+            <a:avLst/>
+          </a:prstGeom>
+        </p:spPr>
+      </p:pic>
+      <p:sp>
+        <p:nvSpPr>
+          <p:cNvPr id="14" name="Text 10"/>
+          <p:cNvSpPr/>
+          <p:nvPr/>
+        </p:nvSpPr>
+        <p:spPr>
+          <a:xfrm>
+            <a:off x="4690872" y="3931920"/>
+            <a:ext cx="2788920" cy="365760"/>
+          </a:xfrm>
+          <a:prstGeom prst="rect">
+            <a:avLst/>
+          </a:prstGeom>
+          <a:noFill/>
+          <a:ln/>
+        </p:spPr>
+        <p:txBody>
+          <a:bodyPr wrap="square" lIns="0" tIns="0" rIns="0" bIns="0" rtlCol="0" anchor="ctr"/>
+          <a:lstStyle/>
+          <a:p>
+            <a:pPr marL="0" indent="0">
+              <a:buNone/>
+            </a:pPr>
+            <a:r>
+              <a:rPr lang="en-US" sz="1700" b="1" dirty="0">
+                <a:solidFill>
+                  <a:srgbClr val="FFFFFF"/>
+                </a:solidFill>
+                <a:latin typeface="Cambria" pitchFamily="34" charset="0"/>
+                <a:ea typeface="Cambria" pitchFamily="34" charset="-122"/>
+                <a:cs typeface="Cambria" pitchFamily="34" charset="-120"/>
+              </a:rPr>
+              <a:t>A forecast rides along</a:t>
+            </a:r>
+            <a:endParaRPr lang="en-US" sz="1700" dirty="0"/>
+          </a:p>
+        </p:txBody>
+      </p:sp>
+      <p:sp>
+        <p:nvSpPr>
+          <p:cNvPr id="15" name="Text 11"/>
+          <p:cNvSpPr/>
+          <p:nvPr/>
+        </p:nvSpPr>
+        <p:spPr>
+          <a:xfrm>
+            <a:off x="4690872" y="4315968"/>
+            <a:ext cx="2788920" cy="914400"/>
+          </a:xfrm>
+          <a:prstGeom prst="rect">
+            <a:avLst/>
+          </a:prstGeom>
+          <a:noFill/>
+          <a:ln/>
+        </p:spPr>
+        <p:txBody>
+          <a:bodyPr wrap="square" lIns="0" tIns="0" rIns="0" bIns="0" rtlCol="0" anchor="t"/>
+          <a:lstStyle/>
+          <a:p>
+            <a:pPr marL="0" indent="0">
+              <a:buNone/>
+            </a:pPr>
+            <a:r>
+              <a:rPr lang="en-US" sz="1250" dirty="0">
+                <a:solidFill>
+                  <a:srgbClr val="C9DDF2"/>
+                </a:solidFill>
+                <a:latin typeface="Calibri" pitchFamily="34" charset="0"/>
+                <a:ea typeface="Calibri" pitchFamily="34" charset="-122"/>
+                <a:cs typeface="Calibri" pitchFamily="34" charset="-120"/>
+              </a:rPr>
+              <a:t>A second brief projects every target to the end of the plan — best, realistic, worst — and says what to do now to stay on track.</a:t>
+            </a:r>
+            <a:endParaRPr lang="en-US" sz="1250" dirty="0"/>
+          </a:p>
+        </p:txBody>
+      </p:sp>
+      <p:sp>
+        <p:nvSpPr>
+          <p:cNvPr id="16" name="Shape 12"/>
+          <p:cNvSpPr/>
+          <p:nvPr/>
+        </p:nvSpPr>
+        <p:spPr>
+          <a:xfrm>
+            <a:off x="8110728" y="2880360"/>
+            <a:ext cx="3383280" cy="2468880"/>
+          </a:xfrm>
+          <a:prstGeom prst="roundRect">
+            <a:avLst>
+              <a:gd name="adj" fmla="val 3704"/>
+            </a:avLst>
+          </a:prstGeom>
+          <a:solidFill>
+            <a:srgbClr val="16395F"/>
+          </a:solidFill>
+          <a:ln w="12700">
+            <a:solidFill>
+              <a:srgbClr val="16395F"/>
+            </a:solidFill>
+            <a:prstDash val="solid"/>
+          </a:ln>
+        </p:spPr>
+      </p:sp>
+      <p:sp>
+        <p:nvSpPr>
+          <p:cNvPr id="17" name="Shape 13"/>
+          <p:cNvSpPr/>
+          <p:nvPr/>
+        </p:nvSpPr>
+        <p:spPr>
+          <a:xfrm>
+            <a:off x="8403336" y="3154680"/>
+            <a:ext cx="640080" cy="640080"/>
+          </a:xfrm>
+          <a:prstGeom prst="ellipse">
+            <a:avLst/>
+          </a:prstGeom>
+          <a:solidFill>
+            <a:srgbClr val="1B6FC2"/>
+          </a:solidFill>
+          <a:ln w="12700">
+            <a:solidFill>
+              <a:srgbClr val="1B6FC2"/>
+            </a:solidFill>
+            <a:prstDash val="solid"/>
+          </a:ln>
+        </p:spPr>
+      </p:sp>
+      <p:pic>
+        <p:nvPicPr>
+          <p:cNvPr id="18" name="Image 2" descr="users icon"/>
+          <p:cNvPicPr>
+            <a:picLocks noChangeAspect="1"/>
+          </p:cNvPicPr>
+          <p:nvPr/>
+        </p:nvPicPr>
+        <p:blipFill>
+          <a:blip r:embed="rId5"/>
+          <a:stretch>
+            <a:fillRect/>
+          </a:stretch>
+        </p:blipFill>
+        <p:spPr>
+          <a:xfrm>
+            <a:off x="8569757" y="3321101"/>
+            <a:ext cx="307238" cy="307238"/>
+          </a:xfrm>
+          <a:prstGeom prst="rect">
+            <a:avLst/>
+          </a:prstGeom>
+        </p:spPr>
+      </p:pic>
+      <p:sp>
+        <p:nvSpPr>
+          <p:cNvPr id="19" name="Text 14"/>
+          <p:cNvSpPr/>
+          <p:nvPr/>
+        </p:nvSpPr>
+        <p:spPr>
+          <a:xfrm>
+            <a:off x="8403336" y="3931920"/>
+            <a:ext cx="2788920" cy="365760"/>
+          </a:xfrm>
+          <a:prstGeom prst="rect">
+            <a:avLst/>
+          </a:prstGeom>
+          <a:noFill/>
+          <a:ln/>
+        </p:spPr>
+        <p:txBody>
+          <a:bodyPr wrap="square" lIns="0" tIns="0" rIns="0" bIns="0" rtlCol="0" anchor="ctr"/>
+          <a:lstStyle/>
+          <a:p>
+            <a:pPr marL="0" indent="0">
+              <a:buNone/>
+            </a:pPr>
+            <a:r>
+              <a:rPr lang="en-US" sz="1700" b="1" dirty="0">
+                <a:solidFill>
+                  <a:srgbClr val="FFFFFF"/>
+                </a:solidFill>
+                <a:latin typeface="Cambria" pitchFamily="34" charset="0"/>
+                <a:ea typeface="Cambria" pitchFamily="34" charset="-122"/>
+                <a:cs typeface="Cambria" pitchFamily="34" charset="-120"/>
+              </a:rPr>
+              <a:t>Sent to the right person</a:t>
+            </a:r>
+            <a:endParaRPr lang="en-US" sz="1700" dirty="0"/>
+          </a:p>
+        </p:txBody>
+      </p:sp>
+      <p:sp>
+        <p:nvSpPr>
+          <p:cNvPr id="20" name="Text 15"/>
+          <p:cNvSpPr/>
+          <p:nvPr/>
+        </p:nvSpPr>
+        <p:spPr>
+          <a:xfrm>
+            <a:off x="8403336" y="4315968"/>
+            <a:ext cx="2788920" cy="914400"/>
+          </a:xfrm>
+          <a:prstGeom prst="rect">
+            <a:avLst/>
+          </a:prstGeom>
+          <a:noFill/>
+          <a:ln/>
+        </p:spPr>
+        <p:txBody>
+          <a:bodyPr wrap="square" lIns="0" tIns="0" rIns="0" bIns="0" rtlCol="0" anchor="t"/>
+          <a:lstStyle/>
+          <a:p>
+            <a:pPr marL="0" indent="0">
+              <a:buNone/>
+            </a:pPr>
+            <a:r>
+              <a:rPr lang="en-US" sz="1250" dirty="0">
+                <a:solidFill>
+                  <a:srgbClr val="C9DDF2"/>
+                </a:solidFill>
+                <a:latin typeface="Calibri" pitchFamily="34" charset="0"/>
+                <a:ea typeface="Calibri" pitchFamily="34" charset="-122"/>
+                <a:cs typeface="Calibri" pitchFamily="34" charset="-120"/>
+              </a:rPr>
+              <a:t>Every scope has a named lead. One click, and each lead receives a personal email with their two PDFs attached.</a:t>
+            </a:r>
+            <a:endParaRPr lang="en-US" sz="1250" dirty="0"/>
+          </a:p>
+        </p:txBody>
+      </p:sp>
+      <p:sp>
+        <p:nvSpPr>
+          <p:cNvPr id="21" name="Text 16"/>
+          <p:cNvSpPr/>
+          <p:nvPr/>
+        </p:nvSpPr>
+        <p:spPr>
+          <a:xfrm>
+            <a:off x="685800" y="5669280"/>
+            <a:ext cx="10789920" cy="457200"/>
+          </a:xfrm>
+          <a:prstGeom prst="rect">
+            <a:avLst/>
+          </a:prstGeom>
+          <a:noFill/>
+          <a:ln/>
+        </p:spPr>
+        <p:txBody>
+          <a:bodyPr wrap="square" lIns="0" tIns="0" rIns="0" bIns="0" rtlCol="0" anchor="ctr"/>
+          <a:lstStyle/>
+          <a:p>
+            <a:pPr marL="0" indent="0" algn="ctr">
+              <a:buNone/>
+            </a:pPr>
+            <a:r>
+              <a:rPr lang="en-US" sz="1600" i="1" dirty="0">
+                <a:solidFill>
+                  <a:srgbClr val="F5B942"/>
+                </a:solidFill>
+                <a:latin typeface="Cambria" pitchFamily="34" charset="0"/>
+                <a:ea typeface="Cambria" pitchFamily="34" charset="-122"/>
+                <a:cs typeface="Cambria" pitchFamily="34" charset="-120"/>
+              </a:rPr>
+              <a:t>No compiling, no chasing, no formatting — the monthly reporting round that used to eat a week is over in a minute.</a:t>
+            </a:r>
+            <a:endParaRPr lang="en-US" sz="1600" dirty="0"/>
           </a:p>
         </p:txBody>
       </p:sp>

</xml_diff>